<commit_message>
docs: nhúng ẢNH MÀN HÌNH THẬT vào deck giới thiệu (34 slide)
Thêm section "Ảnh màn hình thực tế" (6 slide) với ảnh chụp admin-console THẬT (dữ liệu
demo, tông sáng AIPOWER): Control Tower (KPI 52 khách/229 giao dịch/103.6tr), Phân tích
chuyên sâu (lifecycle/doanh thu brand/synergy/nhóm hàng/forecast), Customer 360 + phân
tích hành vi AI (lifecycle/churn/propensity/NBA/cross-sell), AI & Governance (LLM per-task
+ tham số + audit/usage), Trợ lý AI + Data Ops. Ảnh chụp bằng Playwright (e2e/screens.shot
.spec.ts) vào docs/assets/screens/*.png. Deck: 34 slide.

Co-Authored-By: Claude Opus 4.8 (1M context) <noreply@anthropic.com>
Claude-Session: https://claude.ai/code/session_01D8UA5i8UMdwME4xv3Hyy7t
</commit_message>
<xml_diff>
--- a/docs/OCC-CDP-Gioi-thieu-day-du.pptx
+++ b/docs/OCC-CDP-Gioi-thieu-day-du.pptx
@@ -33,6 +33,12 @@
     <p:sldId id="281" r:id="rId32"/>
     <p:sldId id="282" r:id="rId33"/>
     <p:sldId id="283" r:id="rId34"/>
+    <p:sldId id="284" r:id="rId35"/>
+    <p:sldId id="285" r:id="rId36"/>
+    <p:sldId id="286" r:id="rId37"/>
+    <p:sldId id="287" r:id="rId38"/>
+    <p:sldId id="288" r:id="rId39"/>
+    <p:sldId id="289" r:id="rId40"/>
   </p:sldIdLst>
   <p:sldSz cx="12191695" cy="6858000" type="screen4x3"/>
   <p:notesSz cx="6858000" cy="9144000"/>
@@ -26050,7 +26056,7 @@
             <a:avLst/>
           </a:prstGeom>
           <a:solidFill>
-            <a:srgbClr val="FFFFFF"/>
+            <a:srgbClr val="F4F8FD"/>
           </a:solidFill>
           <a:ln>
             <a:noFill/>
@@ -26079,9 +26085,522 @@
           </a:p>
         </p:txBody>
       </p:sp>
+      <p:sp>
+        <p:nvSpPr>
+          <p:cNvPr id="3" name="Rectangle 2"/>
+          <p:cNvSpPr/>
+          <p:nvPr/>
+        </p:nvSpPr>
+        <p:spPr>
+          <a:xfrm>
+            <a:off x="0" y="0"/>
+            <a:ext cx="11148085908000" cy="6270955200000"/>
+          </a:xfrm>
+          <a:prstGeom prst="rect">
+            <a:avLst/>
+          </a:prstGeom>
+          <a:solidFill>
+            <a:srgbClr val="F4F8FD"/>
+          </a:solidFill>
+          <a:ln>
+            <a:noFill/>
+          </a:ln>
+          <a:effectLst/>
+        </p:spPr>
+        <p:style>
+          <a:lnRef idx="1">
+            <a:schemeClr val="accent1"/>
+          </a:lnRef>
+          <a:fillRef idx="3">
+            <a:schemeClr val="accent1"/>
+          </a:fillRef>
+          <a:effectRef idx="2">
+            <a:schemeClr val="accent1"/>
+          </a:effectRef>
+          <a:fontRef idx="minor">
+            <a:schemeClr val="lt1"/>
+          </a:fontRef>
+        </p:style>
+        <p:txBody>
+          <a:bodyPr rtlCol="0" anchor="ctr"/>
+          <a:lstStyle/>
+          <a:p>
+            <a:pPr algn="ctr"/>
+          </a:p>
+        </p:txBody>
+      </p:sp>
+      <p:sp>
+        <p:nvSpPr>
+          <p:cNvPr id="4" name="Rectangle 3"/>
+          <p:cNvSpPr/>
+          <p:nvPr/>
+        </p:nvSpPr>
+        <p:spPr>
+          <a:xfrm>
+            <a:off x="0" y="0"/>
+            <a:ext cx="219456" cy="6858000"/>
+          </a:xfrm>
+          <a:prstGeom prst="rect">
+            <a:avLst/>
+          </a:prstGeom>
+          <a:solidFill>
+            <a:srgbClr val="2563EB"/>
+          </a:solidFill>
+          <a:ln>
+            <a:noFill/>
+          </a:ln>
+          <a:effectLst/>
+        </p:spPr>
+        <p:style>
+          <a:lnRef idx="1">
+            <a:schemeClr val="accent1"/>
+          </a:lnRef>
+          <a:fillRef idx="3">
+            <a:schemeClr val="accent1"/>
+          </a:fillRef>
+          <a:effectRef idx="2">
+            <a:schemeClr val="accent1"/>
+          </a:effectRef>
+          <a:fontRef idx="minor">
+            <a:schemeClr val="lt1"/>
+          </a:fontRef>
+        </p:style>
+        <p:txBody>
+          <a:bodyPr rtlCol="0" anchor="ctr"/>
+          <a:lstStyle/>
+          <a:p>
+            <a:pPr algn="ctr"/>
+          </a:p>
+        </p:txBody>
+      </p:sp>
+      <p:sp>
+        <p:nvSpPr>
+          <p:cNvPr id="5" name="Rounded Rectangle 4"/>
+          <p:cNvSpPr/>
+          <p:nvPr/>
+        </p:nvSpPr>
+        <p:spPr>
+          <a:xfrm>
+            <a:off x="822960" y="2286000"/>
+            <a:ext cx="1828800" cy="1828800"/>
+          </a:xfrm>
+          <a:prstGeom prst="roundRect">
+            <a:avLst>
+              <a:gd name="adj" fmla="val 6000"/>
+            </a:avLst>
+          </a:prstGeom>
+          <a:solidFill>
+            <a:srgbClr val="EEF4FF"/>
+          </a:solidFill>
+          <a:ln>
+            <a:noFill/>
+          </a:ln>
+          <a:effectLst/>
+        </p:spPr>
+        <p:style>
+          <a:lnRef idx="1">
+            <a:schemeClr val="accent1"/>
+          </a:lnRef>
+          <a:fillRef idx="3">
+            <a:schemeClr val="accent1"/>
+          </a:fillRef>
+          <a:effectRef idx="2">
+            <a:schemeClr val="accent1"/>
+          </a:effectRef>
+          <a:fontRef idx="minor">
+            <a:schemeClr val="lt1"/>
+          </a:fontRef>
+        </p:style>
+        <p:txBody>
+          <a:bodyPr rtlCol="0" anchor="ctr"/>
+          <a:lstStyle/>
+          <a:p>
+            <a:pPr algn="ctr"/>
+          </a:p>
+        </p:txBody>
+      </p:sp>
+      <p:sp>
+        <p:nvSpPr>
+          <p:cNvPr id="6" name="TextBox 5"/>
+          <p:cNvSpPr txBox="1"/>
+          <p:nvPr/>
+        </p:nvSpPr>
+        <p:spPr>
+          <a:xfrm>
+            <a:off x="822960" y="2286000"/>
+            <a:ext cx="1828800" cy="1828800"/>
+          </a:xfrm>
+          <a:prstGeom prst="rect">
+            <a:avLst/>
+          </a:prstGeom>
+          <a:noFill/>
+        </p:spPr>
+        <p:txBody>
+          <a:bodyPr wrap="square" anchor="ctr" lIns="0" rIns="0" tIns="0" bIns="0">
+            <a:spAutoFit/>
+          </a:bodyPr>
+          <a:lstStyle/>
+          <a:p>
+            <a:pPr algn="ctr">
+              <a:lnSpc>
+                <a:spcPct val="100000"/>
+              </a:lnSpc>
+              <a:spcBef>
+                <a:spcPts val="0"/>
+              </a:spcBef>
+              <a:spcAft>
+                <a:spcPts val="500"/>
+              </a:spcAft>
+            </a:pPr>
+            <a:r>
+              <a:rPr sz="6600" b="1">
+                <a:solidFill>
+                  <a:srgbClr val="2563EB"/>
+                </a:solidFill>
+                <a:latin typeface="Segoe UI"/>
+              </a:rPr>
+              <a:t>★</a:t>
+            </a:r>
+          </a:p>
+        </p:txBody>
+      </p:sp>
+      <p:sp>
+        <p:nvSpPr>
+          <p:cNvPr id="7" name="TextBox 6"/>
+          <p:cNvSpPr txBox="1"/>
+          <p:nvPr/>
+        </p:nvSpPr>
+        <p:spPr>
+          <a:xfrm>
+            <a:off x="2926080" y="2514600"/>
+            <a:ext cx="8412480" cy="1097280"/>
+          </a:xfrm>
+          <a:prstGeom prst="rect">
+            <a:avLst/>
+          </a:prstGeom>
+          <a:noFill/>
+        </p:spPr>
+        <p:txBody>
+          <a:bodyPr wrap="square" anchor="t" lIns="0" rIns="0" tIns="0" bIns="0">
+            <a:spAutoFit/>
+          </a:bodyPr>
+          <a:lstStyle/>
+          <a:p>
+            <a:pPr algn="l">
+              <a:lnSpc>
+                <a:spcPct val="100000"/>
+              </a:lnSpc>
+              <a:spcBef>
+                <a:spcPts val="0"/>
+              </a:spcBef>
+              <a:spcAft>
+                <a:spcPts val="500"/>
+              </a:spcAft>
+            </a:pPr>
+            <a:r>
+              <a:rPr sz="3400" b="1">
+                <a:solidFill>
+                  <a:srgbClr val="0F172A"/>
+                </a:solidFill>
+                <a:latin typeface="Segoe UI"/>
+              </a:rPr>
+              <a:t>Ảnh màn hình thực tế</a:t>
+            </a:r>
+          </a:p>
+        </p:txBody>
+      </p:sp>
+      <p:sp>
+        <p:nvSpPr>
+          <p:cNvPr id="8" name="TextBox 7"/>
+          <p:cNvSpPr txBox="1"/>
+          <p:nvPr/>
+        </p:nvSpPr>
+        <p:spPr>
+          <a:xfrm>
+            <a:off x="2926080" y="3611880"/>
+            <a:ext cx="8229600" cy="731520"/>
+          </a:xfrm>
+          <a:prstGeom prst="rect">
+            <a:avLst/>
+          </a:prstGeom>
+          <a:noFill/>
+        </p:spPr>
+        <p:txBody>
+          <a:bodyPr wrap="square" anchor="t" lIns="0" rIns="0" tIns="0" bIns="0">
+            <a:spAutoFit/>
+          </a:bodyPr>
+          <a:lstStyle/>
+          <a:p>
+            <a:pPr algn="l">
+              <a:lnSpc>
+                <a:spcPct val="120000"/>
+              </a:lnSpc>
+              <a:spcBef>
+                <a:spcPts val="0"/>
+              </a:spcBef>
+              <a:spcAft>
+                <a:spcPts val="500"/>
+              </a:spcAft>
+            </a:pPr>
+            <a:r>
+              <a:rPr sz="1500" b="0">
+                <a:solidFill>
+                  <a:srgbClr val="475569"/>
+                </a:solidFill>
+                <a:latin typeface="Segoe UI"/>
+              </a:rPr>
+              <a:t>Giao diện thật của admin-console (dữ liệu demo) — để đánh giá trực quan.</a:t>
+            </a:r>
+          </a:p>
+        </p:txBody>
+      </p:sp>
+    </p:spTree>
+  </p:cSld>
+  <p:clrMapOvr>
+    <a:masterClrMapping/>
+  </p:clrMapOvr>
+</p:sld>
+</file>
+
+<file path=ppt/slides/slide29.xml><?xml version="1.0" encoding="utf-8"?>
+<p:sld xmlns:a="http://schemas.openxmlformats.org/drawingml/2006/main" xmlns:p="http://schemas.openxmlformats.org/presentationml/2006/main" xmlns:r="http://schemas.openxmlformats.org/officeDocument/2006/relationships">
+  <p:cSld>
+    <p:spTree>
+      <p:nvGrpSpPr>
+        <p:cNvPr id="1" name=""/>
+        <p:cNvGrpSpPr/>
+        <p:nvPr/>
+      </p:nvGrpSpPr>
+      <p:grpSpPr/>
+      <p:sp>
+        <p:nvSpPr>
+          <p:cNvPr id="2" name="Rectangle 1"/>
+          <p:cNvSpPr/>
+          <p:nvPr/>
+        </p:nvSpPr>
+        <p:spPr>
+          <a:xfrm>
+            <a:off x="0" y="0"/>
+            <a:ext cx="12191695" cy="6858000"/>
+          </a:xfrm>
+          <a:prstGeom prst="rect">
+            <a:avLst/>
+          </a:prstGeom>
+          <a:solidFill>
+            <a:srgbClr val="F4F8FD"/>
+          </a:solidFill>
+          <a:ln>
+            <a:noFill/>
+          </a:ln>
+          <a:effectLst/>
+        </p:spPr>
+        <p:style>
+          <a:lnRef idx="1">
+            <a:schemeClr val="accent1"/>
+          </a:lnRef>
+          <a:fillRef idx="3">
+            <a:schemeClr val="accent1"/>
+          </a:fillRef>
+          <a:effectRef idx="2">
+            <a:schemeClr val="accent1"/>
+          </a:effectRef>
+          <a:fontRef idx="minor">
+            <a:schemeClr val="lt1"/>
+          </a:fontRef>
+        </p:style>
+        <p:txBody>
+          <a:bodyPr rtlCol="0" anchor="ctr"/>
+          <a:lstStyle/>
+          <a:p>
+            <a:pPr algn="ctr"/>
+          </a:p>
+        </p:txBody>
+      </p:sp>
+      <p:sp>
+        <p:nvSpPr>
+          <p:cNvPr id="3" name="Rectangle 2"/>
+          <p:cNvSpPr/>
+          <p:nvPr/>
+        </p:nvSpPr>
+        <p:spPr>
+          <a:xfrm>
+            <a:off x="822960" y="557784"/>
+            <a:ext cx="237744" cy="237744"/>
+          </a:xfrm>
+          <a:prstGeom prst="rect">
+            <a:avLst/>
+          </a:prstGeom>
+          <a:solidFill>
+            <a:srgbClr val="2563EB"/>
+          </a:solidFill>
+          <a:ln>
+            <a:noFill/>
+          </a:ln>
+          <a:effectLst/>
+        </p:spPr>
+        <p:style>
+          <a:lnRef idx="1">
+            <a:schemeClr val="accent1"/>
+          </a:lnRef>
+          <a:fillRef idx="3">
+            <a:schemeClr val="accent1"/>
+          </a:fillRef>
+          <a:effectRef idx="2">
+            <a:schemeClr val="accent1"/>
+          </a:effectRef>
+          <a:fontRef idx="minor">
+            <a:schemeClr val="lt1"/>
+          </a:fontRef>
+        </p:style>
+        <p:txBody>
+          <a:bodyPr rtlCol="0" anchor="ctr"/>
+          <a:lstStyle/>
+          <a:p>
+            <a:pPr algn="ctr"/>
+          </a:p>
+        </p:txBody>
+      </p:sp>
+      <p:sp>
+        <p:nvSpPr>
+          <p:cNvPr id="4" name="TextBox 3"/>
+          <p:cNvSpPr txBox="1"/>
+          <p:nvPr/>
+        </p:nvSpPr>
+        <p:spPr>
+          <a:xfrm>
+            <a:off x="1188720" y="530352"/>
+            <a:ext cx="9144000" cy="365760"/>
+          </a:xfrm>
+          <a:prstGeom prst="rect">
+            <a:avLst/>
+          </a:prstGeom>
+          <a:noFill/>
+        </p:spPr>
+        <p:txBody>
+          <a:bodyPr wrap="square" anchor="t" lIns="0" rIns="0" tIns="0" bIns="0">
+            <a:spAutoFit/>
+          </a:bodyPr>
+          <a:lstStyle/>
+          <a:p>
+            <a:pPr algn="l">
+              <a:lnSpc>
+                <a:spcPct val="100000"/>
+              </a:lnSpc>
+              <a:spcBef>
+                <a:spcPts val="0"/>
+              </a:spcBef>
+              <a:spcAft>
+                <a:spcPts val="500"/>
+              </a:spcAft>
+            </a:pPr>
+            <a:r>
+              <a:rPr sz="1150" b="1">
+                <a:solidFill>
+                  <a:srgbClr val="2563EB"/>
+                </a:solidFill>
+                <a:latin typeface="Segoe UI"/>
+              </a:rPr>
+              <a:t>ẢNH THẬT</a:t>
+            </a:r>
+          </a:p>
+        </p:txBody>
+      </p:sp>
+      <p:sp>
+        <p:nvSpPr>
+          <p:cNvPr id="5" name="TextBox 4"/>
+          <p:cNvSpPr txBox="1"/>
+          <p:nvPr/>
+        </p:nvSpPr>
+        <p:spPr>
+          <a:xfrm>
+            <a:off x="822960" y="841248"/>
+            <a:ext cx="10607040" cy="822960"/>
+          </a:xfrm>
+          <a:prstGeom prst="rect">
+            <a:avLst/>
+          </a:prstGeom>
+          <a:noFill/>
+        </p:spPr>
+        <p:txBody>
+          <a:bodyPr wrap="square" anchor="t" lIns="0" rIns="0" tIns="0" bIns="0">
+            <a:spAutoFit/>
+          </a:bodyPr>
+          <a:lstStyle/>
+          <a:p>
+            <a:pPr algn="l">
+              <a:lnSpc>
+                <a:spcPct val="100000"/>
+              </a:lnSpc>
+              <a:spcBef>
+                <a:spcPts val="0"/>
+              </a:spcBef>
+              <a:spcAft>
+                <a:spcPts val="500"/>
+              </a:spcAft>
+            </a:pPr>
+            <a:r>
+              <a:rPr sz="2700" b="1">
+                <a:solidFill>
+                  <a:srgbClr val="0F172A"/>
+                </a:solidFill>
+                <a:latin typeface="Segoe UI"/>
+              </a:rPr>
+              <a:t>Control Tower — KPI realtime</a:t>
+            </a:r>
+          </a:p>
+        </p:txBody>
+      </p:sp>
+      <p:sp>
+        <p:nvSpPr>
+          <p:cNvPr id="6" name="Rounded Rectangle 5"/>
+          <p:cNvSpPr/>
+          <p:nvPr/>
+        </p:nvSpPr>
+        <p:spPr>
+          <a:xfrm>
+            <a:off x="2835440" y="1527048"/>
+            <a:ext cx="6520815" cy="4663440"/>
+          </a:xfrm>
+          <a:prstGeom prst="roundRect">
+            <a:avLst>
+              <a:gd name="adj" fmla="val 6000"/>
+            </a:avLst>
+          </a:prstGeom>
+          <a:solidFill>
+            <a:srgbClr val="FFFFFF"/>
+          </a:solidFill>
+          <a:ln w="12700">
+            <a:solidFill>
+              <a:srgbClr val="E2E8F0"/>
+            </a:solidFill>
+          </a:ln>
+          <a:effectLst/>
+        </p:spPr>
+        <p:style>
+          <a:lnRef idx="1">
+            <a:schemeClr val="accent1"/>
+          </a:lnRef>
+          <a:fillRef idx="3">
+            <a:schemeClr val="accent1"/>
+          </a:fillRef>
+          <a:effectRef idx="2">
+            <a:schemeClr val="accent1"/>
+          </a:effectRef>
+          <a:fontRef idx="minor">
+            <a:schemeClr val="lt1"/>
+          </a:fontRef>
+        </p:style>
+        <p:txBody>
+          <a:bodyPr rtlCol="0" anchor="ctr"/>
+          <a:lstStyle/>
+          <a:p>
+            <a:pPr algn="ctr"/>
+          </a:p>
+        </p:txBody>
+      </p:sp>
       <p:pic>
         <p:nvPicPr>
-          <p:cNvPr id="3" name="Picture 2" descr="hero.png"/>
+          <p:cNvPr id="7" name="Picture 6" descr="control-tower.png"/>
           <p:cNvPicPr>
             <a:picLocks noChangeAspect="1"/>
           </p:cNvPicPr>
@@ -26095,8 +26614,8 @@
         </p:blipFill>
         <p:spPr>
           <a:xfrm>
-            <a:off x="0" y="0"/>
-            <a:ext cx="12191695" cy="4220202"/>
+            <a:off x="2881160" y="1572768"/>
+            <a:ext cx="6429375" cy="4572000"/>
           </a:xfrm>
           <a:prstGeom prst="rect">
             <a:avLst/>
@@ -26105,58 +26624,14 @@
       </p:pic>
       <p:sp>
         <p:nvSpPr>
-          <p:cNvPr id="4" name="Rectangle 3"/>
-          <p:cNvSpPr/>
-          <p:nvPr/>
-        </p:nvSpPr>
-        <p:spPr>
-          <a:xfrm>
-            <a:off x="0" y="4211058"/>
-            <a:ext cx="12191695" cy="2646941"/>
-          </a:xfrm>
-          <a:prstGeom prst="rect">
-            <a:avLst/>
-          </a:prstGeom>
-          <a:solidFill>
-            <a:srgbClr val="FFFFFF"/>
-          </a:solidFill>
-          <a:ln>
-            <a:noFill/>
-          </a:ln>
-          <a:effectLst/>
-        </p:spPr>
-        <p:style>
-          <a:lnRef idx="1">
-            <a:schemeClr val="accent1"/>
-          </a:lnRef>
-          <a:fillRef idx="3">
-            <a:schemeClr val="accent1"/>
-          </a:fillRef>
-          <a:effectRef idx="2">
-            <a:schemeClr val="accent1"/>
-          </a:effectRef>
-          <a:fontRef idx="minor">
-            <a:schemeClr val="lt1"/>
-          </a:fontRef>
-        </p:style>
-        <p:txBody>
-          <a:bodyPr rtlCol="0" anchor="ctr"/>
-          <a:lstStyle/>
-          <a:p>
-            <a:pPr algn="ctr"/>
-          </a:p>
-        </p:txBody>
-      </p:sp>
-      <p:sp>
-        <p:nvSpPr>
-          <p:cNvPr id="5" name="TextBox 4"/>
-          <p:cNvSpPr txBox="1"/>
-          <p:nvPr/>
-        </p:nvSpPr>
-        <p:spPr>
-          <a:xfrm>
-            <a:off x="822960" y="868680"/>
-            <a:ext cx="10058400" cy="457200"/>
+          <p:cNvPr id="8" name="TextBox 7"/>
+          <p:cNvSpPr txBox="1"/>
+          <p:nvPr/>
+        </p:nvSpPr>
+        <p:spPr>
+          <a:xfrm>
+            <a:off x="822960" y="6272783"/>
+            <a:ext cx="10607040" cy="320040"/>
           </a:xfrm>
           <a:prstGeom prst="rect">
             <a:avLst/>
@@ -26169,7 +26644,7 @@
           </a:bodyPr>
           <a:lstStyle/>
           <a:p>
-            <a:pPr algn="l">
+            <a:pPr algn="ctr">
               <a:lnSpc>
                 <a:spcPct val="100000"/>
               </a:lnSpc>
@@ -26181,27 +26656,27 @@
               </a:spcAft>
             </a:pPr>
             <a:r>
-              <a:rPr sz="1500" b="1">
-                <a:solidFill>
-                  <a:srgbClr val="FFFFFF"/>
-                </a:solidFill>
-                <a:latin typeface="Segoe UI"/>
-              </a:rPr>
-              <a:t>OCC-CDP</a:t>
-            </a:r>
-          </a:p>
-        </p:txBody>
-      </p:sp>
-      <p:sp>
-        <p:nvSpPr>
-          <p:cNvPr id="6" name="TextBox 5"/>
-          <p:cNvSpPr txBox="1"/>
-          <p:nvPr/>
-        </p:nvSpPr>
-        <p:spPr>
-          <a:xfrm>
-            <a:off x="822960" y="1554480"/>
-            <a:ext cx="10607040" cy="1463040"/>
+              <a:rPr sz="1100" b="0">
+                <a:solidFill>
+                  <a:srgbClr val="475569"/>
+                </a:solidFill>
+                <a:latin typeface="Segoe UI"/>
+              </a:rPr>
+              <a:t>KPI tổng hợp 5 thương hiệu, làm mới định kỳ.</a:t>
+            </a:r>
+          </a:p>
+        </p:txBody>
+      </p:sp>
+      <p:sp>
+        <p:nvSpPr>
+          <p:cNvPr id="9" name="TextBox 8"/>
+          <p:cNvSpPr txBox="1"/>
+          <p:nvPr/>
+        </p:nvSpPr>
+        <p:spPr>
+          <a:xfrm>
+            <a:off x="822960" y="6455664"/>
+            <a:ext cx="7315200" cy="274320"/>
           </a:xfrm>
           <a:prstGeom prst="rect">
             <a:avLst/>
@@ -26216,7 +26691,7 @@
           <a:p>
             <a:pPr algn="l">
               <a:lnSpc>
-                <a:spcPct val="105000"/>
+                <a:spcPct val="100000"/>
               </a:lnSpc>
               <a:spcBef>
                 <a:spcPts val="0"/>
@@ -26226,19 +26701,42 @@
               </a:spcAft>
             </a:pPr>
             <a:r>
-              <a:rPr sz="3400" b="1">
-                <a:solidFill>
-                  <a:srgbClr val="FFFFFF"/>
-                </a:solidFill>
-                <a:latin typeface="Segoe UI"/>
-              </a:rPr>
-              <a:t>Một nền dữ liệu.</a:t>
-            </a:r>
-          </a:p>
-          <a:p>
-            <a:pPr algn="l">
-              <a:lnSpc>
-                <a:spcPct val="105000"/>
+              <a:rPr sz="900" b="0">
+                <a:solidFill>
+                  <a:srgbClr val="94A3B8"/>
+                </a:solidFill>
+                <a:latin typeface="Segoe UI"/>
+              </a:rPr>
+              <a:t>OCC-CDP · Tài liệu giới thiệu đầy đủ</a:t>
+            </a:r>
+          </a:p>
+        </p:txBody>
+      </p:sp>
+      <p:sp>
+        <p:nvSpPr>
+          <p:cNvPr id="10" name="TextBox 9"/>
+          <p:cNvSpPr txBox="1"/>
+          <p:nvPr/>
+        </p:nvSpPr>
+        <p:spPr>
+          <a:xfrm>
+            <a:off x="10515600" y="6455664"/>
+            <a:ext cx="822960" cy="274320"/>
+          </a:xfrm>
+          <a:prstGeom prst="rect">
+            <a:avLst/>
+          </a:prstGeom>
+          <a:noFill/>
+        </p:spPr>
+        <p:txBody>
+          <a:bodyPr wrap="square" anchor="t" lIns="0" rIns="0" tIns="0" bIns="0">
+            <a:spAutoFit/>
+          </a:bodyPr>
+          <a:lstStyle/>
+          <a:p>
+            <a:pPr algn="r">
+              <a:lnSpc>
+                <a:spcPct val="100000"/>
               </a:lnSpc>
               <a:spcBef>
                 <a:spcPts val="0"/>
@@ -26248,352 +26746,13 @@
               </a:spcAft>
             </a:pPr>
             <a:r>
-              <a:rPr sz="3400" b="1">
-                <a:solidFill>
-                  <a:srgbClr val="DCEBFF"/>
-                </a:solidFill>
-                <a:latin typeface="Segoe UI"/>
-              </a:rPr>
-              <a:t>Toàn bộ giá trị khách hàng.</a:t>
-            </a:r>
-          </a:p>
-        </p:txBody>
-      </p:sp>
-      <p:sp>
-        <p:nvSpPr>
-          <p:cNvPr id="7" name="Rectangle 6"/>
-          <p:cNvSpPr/>
-          <p:nvPr/>
-        </p:nvSpPr>
-        <p:spPr>
-          <a:xfrm>
-            <a:off x="822960" y="4549386"/>
-            <a:ext cx="137160" cy="137160"/>
-          </a:xfrm>
-          <a:prstGeom prst="rect">
-            <a:avLst/>
-          </a:prstGeom>
-          <a:solidFill>
-            <a:srgbClr val="2563EB"/>
-          </a:solidFill>
-          <a:ln>
-            <a:noFill/>
-          </a:ln>
-          <a:effectLst/>
-        </p:spPr>
-        <p:style>
-          <a:lnRef idx="1">
-            <a:schemeClr val="accent1"/>
-          </a:lnRef>
-          <a:fillRef idx="3">
-            <a:schemeClr val="accent1"/>
-          </a:fillRef>
-          <a:effectRef idx="2">
-            <a:schemeClr val="accent1"/>
-          </a:effectRef>
-          <a:fontRef idx="minor">
-            <a:schemeClr val="lt1"/>
-          </a:fontRef>
-        </p:style>
-        <p:txBody>
-          <a:bodyPr rtlCol="0" anchor="ctr"/>
-          <a:lstStyle/>
-          <a:p>
-            <a:pPr algn="ctr"/>
-          </a:p>
-        </p:txBody>
-      </p:sp>
-      <p:sp>
-        <p:nvSpPr>
-          <p:cNvPr id="8" name="TextBox 7"/>
-          <p:cNvSpPr txBox="1"/>
-          <p:nvPr/>
-        </p:nvSpPr>
-        <p:spPr>
-          <a:xfrm>
-            <a:off x="1097280" y="4494522"/>
-            <a:ext cx="10332720" cy="457200"/>
-          </a:xfrm>
-          <a:prstGeom prst="rect">
-            <a:avLst/>
-          </a:prstGeom>
-          <a:noFill/>
-        </p:spPr>
-        <p:txBody>
-          <a:bodyPr wrap="square" anchor="t" lIns="0" rIns="0" tIns="0" bIns="0">
-            <a:spAutoFit/>
-          </a:bodyPr>
-          <a:lstStyle/>
-          <a:p>
-            <a:pPr algn="l">
-              <a:lnSpc>
-                <a:spcPct val="100000"/>
-              </a:lnSpc>
-              <a:spcBef>
-                <a:spcPts val="0"/>
-              </a:spcBef>
-              <a:spcAft>
-                <a:spcPts val="500"/>
-              </a:spcAft>
-            </a:pPr>
-            <a:r>
-              <a:rPr sz="1400" b="1">
-                <a:solidFill>
-                  <a:srgbClr val="0F172A"/>
-                </a:solidFill>
-                <a:latin typeface="Segoe UI"/>
-              </a:rPr>
-              <a:t>Nền tảng self-host, audit-grade  </a:t>
-            </a:r>
-            <a:r>
-              <a:rPr sz="1250" b="0">
-                <a:solidFill>
-                  <a:srgbClr val="475569"/>
-                </a:solidFill>
-                <a:latin typeface="Segoe UI"/>
-              </a:rPr>
-              <a:t>hợp nhất danh tính · loyalty · consent trong 1 transaction ACID.</a:t>
-            </a:r>
-          </a:p>
-        </p:txBody>
-      </p:sp>
-      <p:sp>
-        <p:nvSpPr>
-          <p:cNvPr id="9" name="Rectangle 8"/>
-          <p:cNvSpPr/>
-          <p:nvPr/>
-        </p:nvSpPr>
-        <p:spPr>
-          <a:xfrm>
-            <a:off x="822960" y="5116314"/>
-            <a:ext cx="137160" cy="137160"/>
-          </a:xfrm>
-          <a:prstGeom prst="rect">
-            <a:avLst/>
-          </a:prstGeom>
-          <a:solidFill>
-            <a:srgbClr val="2563EB"/>
-          </a:solidFill>
-          <a:ln>
-            <a:noFill/>
-          </a:ln>
-          <a:effectLst/>
-        </p:spPr>
-        <p:style>
-          <a:lnRef idx="1">
-            <a:schemeClr val="accent1"/>
-          </a:lnRef>
-          <a:fillRef idx="3">
-            <a:schemeClr val="accent1"/>
-          </a:fillRef>
-          <a:effectRef idx="2">
-            <a:schemeClr val="accent1"/>
-          </a:effectRef>
-          <a:fontRef idx="minor">
-            <a:schemeClr val="lt1"/>
-          </a:fontRef>
-        </p:style>
-        <p:txBody>
-          <a:bodyPr rtlCol="0" anchor="ctr"/>
-          <a:lstStyle/>
-          <a:p>
-            <a:pPr algn="ctr"/>
-          </a:p>
-        </p:txBody>
-      </p:sp>
-      <p:sp>
-        <p:nvSpPr>
-          <p:cNvPr id="10" name="TextBox 9"/>
-          <p:cNvSpPr txBox="1"/>
-          <p:nvPr/>
-        </p:nvSpPr>
-        <p:spPr>
-          <a:xfrm>
-            <a:off x="1097280" y="5061450"/>
-            <a:ext cx="10332720" cy="457200"/>
-          </a:xfrm>
-          <a:prstGeom prst="rect">
-            <a:avLst/>
-          </a:prstGeom>
-          <a:noFill/>
-        </p:spPr>
-        <p:txBody>
-          <a:bodyPr wrap="square" anchor="t" lIns="0" rIns="0" tIns="0" bIns="0">
-            <a:spAutoFit/>
-          </a:bodyPr>
-          <a:lstStyle/>
-          <a:p>
-            <a:pPr algn="l">
-              <a:lnSpc>
-                <a:spcPct val="100000"/>
-              </a:lnSpc>
-              <a:spcBef>
-                <a:spcPts val="0"/>
-              </a:spcBef>
-              <a:spcAft>
-                <a:spcPts val="500"/>
-              </a:spcAft>
-            </a:pPr>
-            <a:r>
-              <a:rPr sz="1400" b="1">
-                <a:solidFill>
-                  <a:srgbClr val="0F172A"/>
-                </a:solidFill>
-                <a:latin typeface="Segoe UI"/>
-              </a:rPr>
-              <a:t>AI biến dữ liệu thành quyết định  </a:t>
-            </a:r>
-            <a:r>
-              <a:rPr sz="1250" b="0">
-                <a:solidFill>
-                  <a:srgbClr val="475569"/>
-                </a:solidFill>
-                <a:latin typeface="Segoe UI"/>
-              </a:rPr>
-              <a:t>phân tích hành vi, dự đoán sản phẩm, forecast, decisioning, copilot.</a:t>
-            </a:r>
-          </a:p>
-        </p:txBody>
-      </p:sp>
-      <p:sp>
-        <p:nvSpPr>
-          <p:cNvPr id="11" name="Rectangle 10"/>
-          <p:cNvSpPr/>
-          <p:nvPr/>
-        </p:nvSpPr>
-        <p:spPr>
-          <a:xfrm>
-            <a:off x="822960" y="5683242"/>
-            <a:ext cx="137160" cy="137160"/>
-          </a:xfrm>
-          <a:prstGeom prst="rect">
-            <a:avLst/>
-          </a:prstGeom>
-          <a:solidFill>
-            <a:srgbClr val="2563EB"/>
-          </a:solidFill>
-          <a:ln>
-            <a:noFill/>
-          </a:ln>
-          <a:effectLst/>
-        </p:spPr>
-        <p:style>
-          <a:lnRef idx="1">
-            <a:schemeClr val="accent1"/>
-          </a:lnRef>
-          <a:fillRef idx="3">
-            <a:schemeClr val="accent1"/>
-          </a:fillRef>
-          <a:effectRef idx="2">
-            <a:schemeClr val="accent1"/>
-          </a:effectRef>
-          <a:fontRef idx="minor">
-            <a:schemeClr val="lt1"/>
-          </a:fontRef>
-        </p:style>
-        <p:txBody>
-          <a:bodyPr rtlCol="0" anchor="ctr"/>
-          <a:lstStyle/>
-          <a:p>
-            <a:pPr algn="ctr"/>
-          </a:p>
-        </p:txBody>
-      </p:sp>
-      <p:sp>
-        <p:nvSpPr>
-          <p:cNvPr id="12" name="TextBox 11"/>
-          <p:cNvSpPr txBox="1"/>
-          <p:nvPr/>
-        </p:nvSpPr>
-        <p:spPr>
-          <a:xfrm>
-            <a:off x="1097280" y="5628378"/>
-            <a:ext cx="10332720" cy="457200"/>
-          </a:xfrm>
-          <a:prstGeom prst="rect">
-            <a:avLst/>
-          </a:prstGeom>
-          <a:noFill/>
-        </p:spPr>
-        <p:txBody>
-          <a:bodyPr wrap="square" anchor="t" lIns="0" rIns="0" tIns="0" bIns="0">
-            <a:spAutoFit/>
-          </a:bodyPr>
-          <a:lstStyle/>
-          <a:p>
-            <a:pPr algn="l">
-              <a:lnSpc>
-                <a:spcPct val="100000"/>
-              </a:lnSpc>
-              <a:spcBef>
-                <a:spcPts val="0"/>
-              </a:spcBef>
-              <a:spcAft>
-                <a:spcPts val="500"/>
-              </a:spcAft>
-            </a:pPr>
-            <a:r>
-              <a:rPr sz="1400" b="1">
-                <a:solidFill>
-                  <a:srgbClr val="0F172A"/>
-                </a:solidFill>
-                <a:latin typeface="Segoe UI"/>
-              </a:rPr>
-              <a:t>Chất lượng chứng minh được  </a:t>
-            </a:r>
-            <a:r>
-              <a:rPr sz="1250" b="0">
-                <a:solidFill>
-                  <a:srgbClr val="475569"/>
-                </a:solidFill>
-                <a:latin typeface="Segoe UI"/>
-              </a:rPr>
-              <a:t>UAT 78/78, expert 33/33, mutation 5/5, TDD toàn diện.</a:t>
-            </a:r>
-          </a:p>
-        </p:txBody>
-      </p:sp>
-      <p:sp>
-        <p:nvSpPr>
-          <p:cNvPr id="13" name="TextBox 12"/>
-          <p:cNvSpPr txBox="1"/>
-          <p:nvPr/>
-        </p:nvSpPr>
-        <p:spPr>
-          <a:xfrm>
-            <a:off x="822960" y="6419088"/>
-            <a:ext cx="10515600" cy="365760"/>
-          </a:xfrm>
-          <a:prstGeom prst="rect">
-            <a:avLst/>
-          </a:prstGeom>
-          <a:noFill/>
-        </p:spPr>
-        <p:txBody>
-          <a:bodyPr wrap="square" anchor="t" lIns="0" rIns="0" tIns="0" bIns="0">
-            <a:spAutoFit/>
-          </a:bodyPr>
-          <a:lstStyle/>
-          <a:p>
-            <a:pPr algn="l">
-              <a:lnSpc>
-                <a:spcPct val="100000"/>
-              </a:lnSpc>
-              <a:spcBef>
-                <a:spcPts val="0"/>
-              </a:spcBef>
-              <a:spcAft>
-                <a:spcPts val="500"/>
-              </a:spcAft>
-            </a:pPr>
-            <a:r>
-              <a:rPr sz="1050" b="0">
+              <a:rPr sz="900" b="0">
                 <a:solidFill>
                   <a:srgbClr val="94A3B8"/>
                 </a:solidFill>
-                <a:latin typeface="Segoe UI"/>
-              </a:rPr>
-              <a:t>Tài liệu chi tiết (markdown): C:\AICDP\docs   ·   github.com/trungtm78/AICDP</a:t>
+                <a:latin typeface="Consolas"/>
+              </a:rPr>
+              <a:t>29</a:t>
             </a:r>
           </a:p>
         </p:txBody>
@@ -27715,6 +27874,2316 @@
                 <a:latin typeface="Consolas"/>
               </a:rPr>
               <a:t>03</a:t>
+            </a:r>
+          </a:p>
+        </p:txBody>
+      </p:sp>
+    </p:spTree>
+  </p:cSld>
+  <p:clrMapOvr>
+    <a:masterClrMapping/>
+  </p:clrMapOvr>
+</p:sld>
+</file>
+
+<file path=ppt/slides/slide30.xml><?xml version="1.0" encoding="utf-8"?>
+<p:sld xmlns:a="http://schemas.openxmlformats.org/drawingml/2006/main" xmlns:p="http://schemas.openxmlformats.org/presentationml/2006/main" xmlns:r="http://schemas.openxmlformats.org/officeDocument/2006/relationships">
+  <p:cSld>
+    <p:spTree>
+      <p:nvGrpSpPr>
+        <p:cNvPr id="1" name=""/>
+        <p:cNvGrpSpPr/>
+        <p:nvPr/>
+      </p:nvGrpSpPr>
+      <p:grpSpPr/>
+      <p:sp>
+        <p:nvSpPr>
+          <p:cNvPr id="2" name="Rectangle 1"/>
+          <p:cNvSpPr/>
+          <p:nvPr/>
+        </p:nvSpPr>
+        <p:spPr>
+          <a:xfrm>
+            <a:off x="0" y="0"/>
+            <a:ext cx="12191695" cy="6858000"/>
+          </a:xfrm>
+          <a:prstGeom prst="rect">
+            <a:avLst/>
+          </a:prstGeom>
+          <a:solidFill>
+            <a:srgbClr val="F4F8FD"/>
+          </a:solidFill>
+          <a:ln>
+            <a:noFill/>
+          </a:ln>
+          <a:effectLst/>
+        </p:spPr>
+        <p:style>
+          <a:lnRef idx="1">
+            <a:schemeClr val="accent1"/>
+          </a:lnRef>
+          <a:fillRef idx="3">
+            <a:schemeClr val="accent1"/>
+          </a:fillRef>
+          <a:effectRef idx="2">
+            <a:schemeClr val="accent1"/>
+          </a:effectRef>
+          <a:fontRef idx="minor">
+            <a:schemeClr val="lt1"/>
+          </a:fontRef>
+        </p:style>
+        <p:txBody>
+          <a:bodyPr rtlCol="0" anchor="ctr"/>
+          <a:lstStyle/>
+          <a:p>
+            <a:pPr algn="ctr"/>
+          </a:p>
+        </p:txBody>
+      </p:sp>
+      <p:sp>
+        <p:nvSpPr>
+          <p:cNvPr id="3" name="Rectangle 2"/>
+          <p:cNvSpPr/>
+          <p:nvPr/>
+        </p:nvSpPr>
+        <p:spPr>
+          <a:xfrm>
+            <a:off x="822960" y="557784"/>
+            <a:ext cx="237744" cy="237744"/>
+          </a:xfrm>
+          <a:prstGeom prst="rect">
+            <a:avLst/>
+          </a:prstGeom>
+          <a:solidFill>
+            <a:srgbClr val="2563EB"/>
+          </a:solidFill>
+          <a:ln>
+            <a:noFill/>
+          </a:ln>
+          <a:effectLst/>
+        </p:spPr>
+        <p:style>
+          <a:lnRef idx="1">
+            <a:schemeClr val="accent1"/>
+          </a:lnRef>
+          <a:fillRef idx="3">
+            <a:schemeClr val="accent1"/>
+          </a:fillRef>
+          <a:effectRef idx="2">
+            <a:schemeClr val="accent1"/>
+          </a:effectRef>
+          <a:fontRef idx="minor">
+            <a:schemeClr val="lt1"/>
+          </a:fontRef>
+        </p:style>
+        <p:txBody>
+          <a:bodyPr rtlCol="0" anchor="ctr"/>
+          <a:lstStyle/>
+          <a:p>
+            <a:pPr algn="ctr"/>
+          </a:p>
+        </p:txBody>
+      </p:sp>
+      <p:sp>
+        <p:nvSpPr>
+          <p:cNvPr id="4" name="TextBox 3"/>
+          <p:cNvSpPr txBox="1"/>
+          <p:nvPr/>
+        </p:nvSpPr>
+        <p:spPr>
+          <a:xfrm>
+            <a:off x="1188720" y="530352"/>
+            <a:ext cx="9144000" cy="365760"/>
+          </a:xfrm>
+          <a:prstGeom prst="rect">
+            <a:avLst/>
+          </a:prstGeom>
+          <a:noFill/>
+        </p:spPr>
+        <p:txBody>
+          <a:bodyPr wrap="square" anchor="t" lIns="0" rIns="0" tIns="0" bIns="0">
+            <a:spAutoFit/>
+          </a:bodyPr>
+          <a:lstStyle/>
+          <a:p>
+            <a:pPr algn="l">
+              <a:lnSpc>
+                <a:spcPct val="100000"/>
+              </a:lnSpc>
+              <a:spcBef>
+                <a:spcPts val="0"/>
+              </a:spcBef>
+              <a:spcAft>
+                <a:spcPts val="500"/>
+              </a:spcAft>
+            </a:pPr>
+            <a:r>
+              <a:rPr sz="1150" b="1">
+                <a:solidFill>
+                  <a:srgbClr val="2563EB"/>
+                </a:solidFill>
+                <a:latin typeface="Segoe UI"/>
+              </a:rPr>
+              <a:t>ẢNH THẬT</a:t>
+            </a:r>
+          </a:p>
+        </p:txBody>
+      </p:sp>
+      <p:sp>
+        <p:nvSpPr>
+          <p:cNvPr id="5" name="TextBox 4"/>
+          <p:cNvSpPr txBox="1"/>
+          <p:nvPr/>
+        </p:nvSpPr>
+        <p:spPr>
+          <a:xfrm>
+            <a:off x="822960" y="841248"/>
+            <a:ext cx="10607040" cy="822960"/>
+          </a:xfrm>
+          <a:prstGeom prst="rect">
+            <a:avLst/>
+          </a:prstGeom>
+          <a:noFill/>
+        </p:spPr>
+        <p:txBody>
+          <a:bodyPr wrap="square" anchor="t" lIns="0" rIns="0" tIns="0" bIns="0">
+            <a:spAutoFit/>
+          </a:bodyPr>
+          <a:lstStyle/>
+          <a:p>
+            <a:pPr algn="l">
+              <a:lnSpc>
+                <a:spcPct val="100000"/>
+              </a:lnSpc>
+              <a:spcBef>
+                <a:spcPts val="0"/>
+              </a:spcBef>
+              <a:spcAft>
+                <a:spcPts val="500"/>
+              </a:spcAft>
+            </a:pPr>
+            <a:r>
+              <a:rPr sz="2700" b="1">
+                <a:solidFill>
+                  <a:srgbClr val="0F172A"/>
+                </a:solidFill>
+                <a:latin typeface="Segoe UI"/>
+              </a:rPr>
+              <a:t>Phân tích chuyên sâu</a:t>
+            </a:r>
+          </a:p>
+        </p:txBody>
+      </p:sp>
+      <p:sp>
+        <p:nvSpPr>
+          <p:cNvPr id="6" name="Rounded Rectangle 5"/>
+          <p:cNvSpPr/>
+          <p:nvPr/>
+        </p:nvSpPr>
+        <p:spPr>
+          <a:xfrm>
+            <a:off x="2835440" y="1527048"/>
+            <a:ext cx="6520815" cy="4663440"/>
+          </a:xfrm>
+          <a:prstGeom prst="roundRect">
+            <a:avLst>
+              <a:gd name="adj" fmla="val 6000"/>
+            </a:avLst>
+          </a:prstGeom>
+          <a:solidFill>
+            <a:srgbClr val="FFFFFF"/>
+          </a:solidFill>
+          <a:ln w="12700">
+            <a:solidFill>
+              <a:srgbClr val="E2E8F0"/>
+            </a:solidFill>
+          </a:ln>
+          <a:effectLst/>
+        </p:spPr>
+        <p:style>
+          <a:lnRef idx="1">
+            <a:schemeClr val="accent1"/>
+          </a:lnRef>
+          <a:fillRef idx="3">
+            <a:schemeClr val="accent1"/>
+          </a:fillRef>
+          <a:effectRef idx="2">
+            <a:schemeClr val="accent1"/>
+          </a:effectRef>
+          <a:fontRef idx="minor">
+            <a:schemeClr val="lt1"/>
+          </a:fontRef>
+        </p:style>
+        <p:txBody>
+          <a:bodyPr rtlCol="0" anchor="ctr"/>
+          <a:lstStyle/>
+          <a:p>
+            <a:pPr algn="ctr"/>
+          </a:p>
+        </p:txBody>
+      </p:sp>
+      <p:pic>
+        <p:nvPicPr>
+          <p:cNvPr id="7" name="Picture 6" descr="insights.png"/>
+          <p:cNvPicPr>
+            <a:picLocks noChangeAspect="1"/>
+          </p:cNvPicPr>
+          <p:nvPr/>
+        </p:nvPicPr>
+        <p:blipFill>
+          <a:blip r:embed="rId2"/>
+          <a:stretch>
+            <a:fillRect/>
+          </a:stretch>
+        </p:blipFill>
+        <p:spPr>
+          <a:xfrm>
+            <a:off x="2881160" y="1572768"/>
+            <a:ext cx="6429375" cy="4572000"/>
+          </a:xfrm>
+          <a:prstGeom prst="rect">
+            <a:avLst/>
+          </a:prstGeom>
+        </p:spPr>
+      </p:pic>
+      <p:sp>
+        <p:nvSpPr>
+          <p:cNvPr id="8" name="TextBox 7"/>
+          <p:cNvSpPr txBox="1"/>
+          <p:nvPr/>
+        </p:nvSpPr>
+        <p:spPr>
+          <a:xfrm>
+            <a:off x="822960" y="6272783"/>
+            <a:ext cx="10607040" cy="320040"/>
+          </a:xfrm>
+          <a:prstGeom prst="rect">
+            <a:avLst/>
+          </a:prstGeom>
+          <a:noFill/>
+        </p:spPr>
+        <p:txBody>
+          <a:bodyPr wrap="square" anchor="t" lIns="0" rIns="0" tIns="0" bIns="0">
+            <a:spAutoFit/>
+          </a:bodyPr>
+          <a:lstStyle/>
+          <a:p>
+            <a:pPr algn="ctr">
+              <a:lnSpc>
+                <a:spcPct val="100000"/>
+              </a:lnSpc>
+              <a:spcBef>
+                <a:spcPts val="0"/>
+              </a:spcBef>
+              <a:spcAft>
+                <a:spcPts val="500"/>
+              </a:spcAft>
+            </a:pPr>
+            <a:r>
+              <a:rPr sz="1100" b="0">
+                <a:solidFill>
+                  <a:srgbClr val="475569"/>
+                </a:solidFill>
+                <a:latin typeface="Segoe UI"/>
+              </a:rPr>
+              <a:t>Vòng đời khách · doanh thu theo brand · synergy cross-brand · nhóm hàng · dự báo doanh thu.</a:t>
+            </a:r>
+          </a:p>
+        </p:txBody>
+      </p:sp>
+      <p:sp>
+        <p:nvSpPr>
+          <p:cNvPr id="9" name="TextBox 8"/>
+          <p:cNvSpPr txBox="1"/>
+          <p:nvPr/>
+        </p:nvSpPr>
+        <p:spPr>
+          <a:xfrm>
+            <a:off x="822960" y="6455664"/>
+            <a:ext cx="7315200" cy="274320"/>
+          </a:xfrm>
+          <a:prstGeom prst="rect">
+            <a:avLst/>
+          </a:prstGeom>
+          <a:noFill/>
+        </p:spPr>
+        <p:txBody>
+          <a:bodyPr wrap="square" anchor="t" lIns="0" rIns="0" tIns="0" bIns="0">
+            <a:spAutoFit/>
+          </a:bodyPr>
+          <a:lstStyle/>
+          <a:p>
+            <a:pPr algn="l">
+              <a:lnSpc>
+                <a:spcPct val="100000"/>
+              </a:lnSpc>
+              <a:spcBef>
+                <a:spcPts val="0"/>
+              </a:spcBef>
+              <a:spcAft>
+                <a:spcPts val="500"/>
+              </a:spcAft>
+            </a:pPr>
+            <a:r>
+              <a:rPr sz="900" b="0">
+                <a:solidFill>
+                  <a:srgbClr val="94A3B8"/>
+                </a:solidFill>
+                <a:latin typeface="Segoe UI"/>
+              </a:rPr>
+              <a:t>OCC-CDP · Tài liệu giới thiệu đầy đủ</a:t>
+            </a:r>
+          </a:p>
+        </p:txBody>
+      </p:sp>
+      <p:sp>
+        <p:nvSpPr>
+          <p:cNvPr id="10" name="TextBox 9"/>
+          <p:cNvSpPr txBox="1"/>
+          <p:nvPr/>
+        </p:nvSpPr>
+        <p:spPr>
+          <a:xfrm>
+            <a:off x="10515600" y="6455664"/>
+            <a:ext cx="822960" cy="274320"/>
+          </a:xfrm>
+          <a:prstGeom prst="rect">
+            <a:avLst/>
+          </a:prstGeom>
+          <a:noFill/>
+        </p:spPr>
+        <p:txBody>
+          <a:bodyPr wrap="square" anchor="t" lIns="0" rIns="0" tIns="0" bIns="0">
+            <a:spAutoFit/>
+          </a:bodyPr>
+          <a:lstStyle/>
+          <a:p>
+            <a:pPr algn="r">
+              <a:lnSpc>
+                <a:spcPct val="100000"/>
+              </a:lnSpc>
+              <a:spcBef>
+                <a:spcPts val="0"/>
+              </a:spcBef>
+              <a:spcAft>
+                <a:spcPts val="500"/>
+              </a:spcAft>
+            </a:pPr>
+            <a:r>
+              <a:rPr sz="900" b="0">
+                <a:solidFill>
+                  <a:srgbClr val="94A3B8"/>
+                </a:solidFill>
+                <a:latin typeface="Consolas"/>
+              </a:rPr>
+              <a:t>30</a:t>
+            </a:r>
+          </a:p>
+        </p:txBody>
+      </p:sp>
+    </p:spTree>
+  </p:cSld>
+  <p:clrMapOvr>
+    <a:masterClrMapping/>
+  </p:clrMapOvr>
+</p:sld>
+</file>
+
+<file path=ppt/slides/slide31.xml><?xml version="1.0" encoding="utf-8"?>
+<p:sld xmlns:a="http://schemas.openxmlformats.org/drawingml/2006/main" xmlns:p="http://schemas.openxmlformats.org/presentationml/2006/main" xmlns:r="http://schemas.openxmlformats.org/officeDocument/2006/relationships">
+  <p:cSld>
+    <p:spTree>
+      <p:nvGrpSpPr>
+        <p:cNvPr id="1" name=""/>
+        <p:cNvGrpSpPr/>
+        <p:nvPr/>
+      </p:nvGrpSpPr>
+      <p:grpSpPr/>
+      <p:sp>
+        <p:nvSpPr>
+          <p:cNvPr id="2" name="Rectangle 1"/>
+          <p:cNvSpPr/>
+          <p:nvPr/>
+        </p:nvSpPr>
+        <p:spPr>
+          <a:xfrm>
+            <a:off x="0" y="0"/>
+            <a:ext cx="12191695" cy="6858000"/>
+          </a:xfrm>
+          <a:prstGeom prst="rect">
+            <a:avLst/>
+          </a:prstGeom>
+          <a:solidFill>
+            <a:srgbClr val="F4F8FD"/>
+          </a:solidFill>
+          <a:ln>
+            <a:noFill/>
+          </a:ln>
+          <a:effectLst/>
+        </p:spPr>
+        <p:style>
+          <a:lnRef idx="1">
+            <a:schemeClr val="accent1"/>
+          </a:lnRef>
+          <a:fillRef idx="3">
+            <a:schemeClr val="accent1"/>
+          </a:fillRef>
+          <a:effectRef idx="2">
+            <a:schemeClr val="accent1"/>
+          </a:effectRef>
+          <a:fontRef idx="minor">
+            <a:schemeClr val="lt1"/>
+          </a:fontRef>
+        </p:style>
+        <p:txBody>
+          <a:bodyPr rtlCol="0" anchor="ctr"/>
+          <a:lstStyle/>
+          <a:p>
+            <a:pPr algn="ctr"/>
+          </a:p>
+        </p:txBody>
+      </p:sp>
+      <p:sp>
+        <p:nvSpPr>
+          <p:cNvPr id="3" name="Rectangle 2"/>
+          <p:cNvSpPr/>
+          <p:nvPr/>
+        </p:nvSpPr>
+        <p:spPr>
+          <a:xfrm>
+            <a:off x="822960" y="557784"/>
+            <a:ext cx="237744" cy="237744"/>
+          </a:xfrm>
+          <a:prstGeom prst="rect">
+            <a:avLst/>
+          </a:prstGeom>
+          <a:solidFill>
+            <a:srgbClr val="2563EB"/>
+          </a:solidFill>
+          <a:ln>
+            <a:noFill/>
+          </a:ln>
+          <a:effectLst/>
+        </p:spPr>
+        <p:style>
+          <a:lnRef idx="1">
+            <a:schemeClr val="accent1"/>
+          </a:lnRef>
+          <a:fillRef idx="3">
+            <a:schemeClr val="accent1"/>
+          </a:fillRef>
+          <a:effectRef idx="2">
+            <a:schemeClr val="accent1"/>
+          </a:effectRef>
+          <a:fontRef idx="minor">
+            <a:schemeClr val="lt1"/>
+          </a:fontRef>
+        </p:style>
+        <p:txBody>
+          <a:bodyPr rtlCol="0" anchor="ctr"/>
+          <a:lstStyle/>
+          <a:p>
+            <a:pPr algn="ctr"/>
+          </a:p>
+        </p:txBody>
+      </p:sp>
+      <p:sp>
+        <p:nvSpPr>
+          <p:cNvPr id="4" name="TextBox 3"/>
+          <p:cNvSpPr txBox="1"/>
+          <p:nvPr/>
+        </p:nvSpPr>
+        <p:spPr>
+          <a:xfrm>
+            <a:off x="1188720" y="530352"/>
+            <a:ext cx="9144000" cy="365760"/>
+          </a:xfrm>
+          <a:prstGeom prst="rect">
+            <a:avLst/>
+          </a:prstGeom>
+          <a:noFill/>
+        </p:spPr>
+        <p:txBody>
+          <a:bodyPr wrap="square" anchor="t" lIns="0" rIns="0" tIns="0" bIns="0">
+            <a:spAutoFit/>
+          </a:bodyPr>
+          <a:lstStyle/>
+          <a:p>
+            <a:pPr algn="l">
+              <a:lnSpc>
+                <a:spcPct val="100000"/>
+              </a:lnSpc>
+              <a:spcBef>
+                <a:spcPts val="0"/>
+              </a:spcBef>
+              <a:spcAft>
+                <a:spcPts val="500"/>
+              </a:spcAft>
+            </a:pPr>
+            <a:r>
+              <a:rPr sz="1150" b="1">
+                <a:solidFill>
+                  <a:srgbClr val="2563EB"/>
+                </a:solidFill>
+                <a:latin typeface="Segoe UI"/>
+              </a:rPr>
+              <a:t>ẢNH THẬT</a:t>
+            </a:r>
+          </a:p>
+        </p:txBody>
+      </p:sp>
+      <p:sp>
+        <p:nvSpPr>
+          <p:cNvPr id="5" name="TextBox 4"/>
+          <p:cNvSpPr txBox="1"/>
+          <p:nvPr/>
+        </p:nvSpPr>
+        <p:spPr>
+          <a:xfrm>
+            <a:off x="822960" y="841248"/>
+            <a:ext cx="10607040" cy="822960"/>
+          </a:xfrm>
+          <a:prstGeom prst="rect">
+            <a:avLst/>
+          </a:prstGeom>
+          <a:noFill/>
+        </p:spPr>
+        <p:txBody>
+          <a:bodyPr wrap="square" anchor="t" lIns="0" rIns="0" tIns="0" bIns="0">
+            <a:spAutoFit/>
+          </a:bodyPr>
+          <a:lstStyle/>
+          <a:p>
+            <a:pPr algn="l">
+              <a:lnSpc>
+                <a:spcPct val="100000"/>
+              </a:lnSpc>
+              <a:spcBef>
+                <a:spcPts val="0"/>
+              </a:spcBef>
+              <a:spcAft>
+                <a:spcPts val="500"/>
+              </a:spcAft>
+            </a:pPr>
+            <a:r>
+              <a:rPr sz="2700" b="1">
+                <a:solidFill>
+                  <a:srgbClr val="0F172A"/>
+                </a:solidFill>
+                <a:latin typeface="Segoe UI"/>
+              </a:rPr>
+              <a:t>Customer 360 + phân tích hành vi AI</a:t>
+            </a:r>
+          </a:p>
+        </p:txBody>
+      </p:sp>
+      <p:sp>
+        <p:nvSpPr>
+          <p:cNvPr id="6" name="Rounded Rectangle 5"/>
+          <p:cNvSpPr/>
+          <p:nvPr/>
+        </p:nvSpPr>
+        <p:spPr>
+          <a:xfrm>
+            <a:off x="2835440" y="1527048"/>
+            <a:ext cx="6520815" cy="4663440"/>
+          </a:xfrm>
+          <a:prstGeom prst="roundRect">
+            <a:avLst>
+              <a:gd name="adj" fmla="val 6000"/>
+            </a:avLst>
+          </a:prstGeom>
+          <a:solidFill>
+            <a:srgbClr val="FFFFFF"/>
+          </a:solidFill>
+          <a:ln w="12700">
+            <a:solidFill>
+              <a:srgbClr val="E2E8F0"/>
+            </a:solidFill>
+          </a:ln>
+          <a:effectLst/>
+        </p:spPr>
+        <p:style>
+          <a:lnRef idx="1">
+            <a:schemeClr val="accent1"/>
+          </a:lnRef>
+          <a:fillRef idx="3">
+            <a:schemeClr val="accent1"/>
+          </a:fillRef>
+          <a:effectRef idx="2">
+            <a:schemeClr val="accent1"/>
+          </a:effectRef>
+          <a:fontRef idx="minor">
+            <a:schemeClr val="lt1"/>
+          </a:fontRef>
+        </p:style>
+        <p:txBody>
+          <a:bodyPr rtlCol="0" anchor="ctr"/>
+          <a:lstStyle/>
+          <a:p>
+            <a:pPr algn="ctr"/>
+          </a:p>
+        </p:txBody>
+      </p:sp>
+      <p:pic>
+        <p:nvPicPr>
+          <p:cNvPr id="7" name="Picture 6" descr="customer360.png"/>
+          <p:cNvPicPr>
+            <a:picLocks noChangeAspect="1"/>
+          </p:cNvPicPr>
+          <p:nvPr/>
+        </p:nvPicPr>
+        <p:blipFill>
+          <a:blip r:embed="rId2"/>
+          <a:stretch>
+            <a:fillRect/>
+          </a:stretch>
+        </p:blipFill>
+        <p:spPr>
+          <a:xfrm>
+            <a:off x="2881160" y="1572768"/>
+            <a:ext cx="6429375" cy="4572000"/>
+          </a:xfrm>
+          <a:prstGeom prst="rect">
+            <a:avLst/>
+          </a:prstGeom>
+        </p:spPr>
+      </p:pic>
+      <p:sp>
+        <p:nvSpPr>
+          <p:cNvPr id="8" name="TextBox 7"/>
+          <p:cNvSpPr txBox="1"/>
+          <p:nvPr/>
+        </p:nvSpPr>
+        <p:spPr>
+          <a:xfrm>
+            <a:off x="822960" y="6272783"/>
+            <a:ext cx="10607040" cy="320040"/>
+          </a:xfrm>
+          <a:prstGeom prst="rect">
+            <a:avLst/>
+          </a:prstGeom>
+          <a:noFill/>
+        </p:spPr>
+        <p:txBody>
+          <a:bodyPr wrap="square" anchor="t" lIns="0" rIns="0" tIns="0" bIns="0">
+            <a:spAutoFit/>
+          </a:bodyPr>
+          <a:lstStyle/>
+          <a:p>
+            <a:pPr algn="ctr">
+              <a:lnSpc>
+                <a:spcPct val="100000"/>
+              </a:lnSpc>
+              <a:spcBef>
+                <a:spcPts val="0"/>
+              </a:spcBef>
+              <a:spcAft>
+                <a:spcPts val="500"/>
+              </a:spcAft>
+            </a:pPr>
+            <a:r>
+              <a:rPr sz="1100" b="0">
+                <a:solidFill>
+                  <a:srgbClr val="475569"/>
+                </a:solidFill>
+                <a:latin typeface="Segoe UI"/>
+              </a:rPr>
+              <a:t>Hồ sơ hợp nhất · lifecycle/churn/propensity · Next-Best-Action · gợi ý cross-sell (AI).</a:t>
+            </a:r>
+          </a:p>
+        </p:txBody>
+      </p:sp>
+      <p:sp>
+        <p:nvSpPr>
+          <p:cNvPr id="9" name="TextBox 8"/>
+          <p:cNvSpPr txBox="1"/>
+          <p:nvPr/>
+        </p:nvSpPr>
+        <p:spPr>
+          <a:xfrm>
+            <a:off x="822960" y="6455664"/>
+            <a:ext cx="7315200" cy="274320"/>
+          </a:xfrm>
+          <a:prstGeom prst="rect">
+            <a:avLst/>
+          </a:prstGeom>
+          <a:noFill/>
+        </p:spPr>
+        <p:txBody>
+          <a:bodyPr wrap="square" anchor="t" lIns="0" rIns="0" tIns="0" bIns="0">
+            <a:spAutoFit/>
+          </a:bodyPr>
+          <a:lstStyle/>
+          <a:p>
+            <a:pPr algn="l">
+              <a:lnSpc>
+                <a:spcPct val="100000"/>
+              </a:lnSpc>
+              <a:spcBef>
+                <a:spcPts val="0"/>
+              </a:spcBef>
+              <a:spcAft>
+                <a:spcPts val="500"/>
+              </a:spcAft>
+            </a:pPr>
+            <a:r>
+              <a:rPr sz="900" b="0">
+                <a:solidFill>
+                  <a:srgbClr val="94A3B8"/>
+                </a:solidFill>
+                <a:latin typeface="Segoe UI"/>
+              </a:rPr>
+              <a:t>OCC-CDP · Tài liệu giới thiệu đầy đủ</a:t>
+            </a:r>
+          </a:p>
+        </p:txBody>
+      </p:sp>
+      <p:sp>
+        <p:nvSpPr>
+          <p:cNvPr id="10" name="TextBox 9"/>
+          <p:cNvSpPr txBox="1"/>
+          <p:nvPr/>
+        </p:nvSpPr>
+        <p:spPr>
+          <a:xfrm>
+            <a:off x="10515600" y="6455664"/>
+            <a:ext cx="822960" cy="274320"/>
+          </a:xfrm>
+          <a:prstGeom prst="rect">
+            <a:avLst/>
+          </a:prstGeom>
+          <a:noFill/>
+        </p:spPr>
+        <p:txBody>
+          <a:bodyPr wrap="square" anchor="t" lIns="0" rIns="0" tIns="0" bIns="0">
+            <a:spAutoFit/>
+          </a:bodyPr>
+          <a:lstStyle/>
+          <a:p>
+            <a:pPr algn="r">
+              <a:lnSpc>
+                <a:spcPct val="100000"/>
+              </a:lnSpc>
+              <a:spcBef>
+                <a:spcPts val="0"/>
+              </a:spcBef>
+              <a:spcAft>
+                <a:spcPts val="500"/>
+              </a:spcAft>
+            </a:pPr>
+            <a:r>
+              <a:rPr sz="900" b="0">
+                <a:solidFill>
+                  <a:srgbClr val="94A3B8"/>
+                </a:solidFill>
+                <a:latin typeface="Consolas"/>
+              </a:rPr>
+              <a:t>31</a:t>
+            </a:r>
+          </a:p>
+        </p:txBody>
+      </p:sp>
+    </p:spTree>
+  </p:cSld>
+  <p:clrMapOvr>
+    <a:masterClrMapping/>
+  </p:clrMapOvr>
+</p:sld>
+</file>
+
+<file path=ppt/slides/slide32.xml><?xml version="1.0" encoding="utf-8"?>
+<p:sld xmlns:a="http://schemas.openxmlformats.org/drawingml/2006/main" xmlns:p="http://schemas.openxmlformats.org/presentationml/2006/main" xmlns:r="http://schemas.openxmlformats.org/officeDocument/2006/relationships">
+  <p:cSld>
+    <p:spTree>
+      <p:nvGrpSpPr>
+        <p:cNvPr id="1" name=""/>
+        <p:cNvGrpSpPr/>
+        <p:nvPr/>
+      </p:nvGrpSpPr>
+      <p:grpSpPr/>
+      <p:sp>
+        <p:nvSpPr>
+          <p:cNvPr id="2" name="Rectangle 1"/>
+          <p:cNvSpPr/>
+          <p:nvPr/>
+        </p:nvSpPr>
+        <p:spPr>
+          <a:xfrm>
+            <a:off x="0" y="0"/>
+            <a:ext cx="12191695" cy="6858000"/>
+          </a:xfrm>
+          <a:prstGeom prst="rect">
+            <a:avLst/>
+          </a:prstGeom>
+          <a:solidFill>
+            <a:srgbClr val="F4F8FD"/>
+          </a:solidFill>
+          <a:ln>
+            <a:noFill/>
+          </a:ln>
+          <a:effectLst/>
+        </p:spPr>
+        <p:style>
+          <a:lnRef idx="1">
+            <a:schemeClr val="accent1"/>
+          </a:lnRef>
+          <a:fillRef idx="3">
+            <a:schemeClr val="accent1"/>
+          </a:fillRef>
+          <a:effectRef idx="2">
+            <a:schemeClr val="accent1"/>
+          </a:effectRef>
+          <a:fontRef idx="minor">
+            <a:schemeClr val="lt1"/>
+          </a:fontRef>
+        </p:style>
+        <p:txBody>
+          <a:bodyPr rtlCol="0" anchor="ctr"/>
+          <a:lstStyle/>
+          <a:p>
+            <a:pPr algn="ctr"/>
+          </a:p>
+        </p:txBody>
+      </p:sp>
+      <p:sp>
+        <p:nvSpPr>
+          <p:cNvPr id="3" name="Rectangle 2"/>
+          <p:cNvSpPr/>
+          <p:nvPr/>
+        </p:nvSpPr>
+        <p:spPr>
+          <a:xfrm>
+            <a:off x="822960" y="557784"/>
+            <a:ext cx="237744" cy="237744"/>
+          </a:xfrm>
+          <a:prstGeom prst="rect">
+            <a:avLst/>
+          </a:prstGeom>
+          <a:solidFill>
+            <a:srgbClr val="2563EB"/>
+          </a:solidFill>
+          <a:ln>
+            <a:noFill/>
+          </a:ln>
+          <a:effectLst/>
+        </p:spPr>
+        <p:style>
+          <a:lnRef idx="1">
+            <a:schemeClr val="accent1"/>
+          </a:lnRef>
+          <a:fillRef idx="3">
+            <a:schemeClr val="accent1"/>
+          </a:fillRef>
+          <a:effectRef idx="2">
+            <a:schemeClr val="accent1"/>
+          </a:effectRef>
+          <a:fontRef idx="minor">
+            <a:schemeClr val="lt1"/>
+          </a:fontRef>
+        </p:style>
+        <p:txBody>
+          <a:bodyPr rtlCol="0" anchor="ctr"/>
+          <a:lstStyle/>
+          <a:p>
+            <a:pPr algn="ctr"/>
+          </a:p>
+        </p:txBody>
+      </p:sp>
+      <p:sp>
+        <p:nvSpPr>
+          <p:cNvPr id="4" name="TextBox 3"/>
+          <p:cNvSpPr txBox="1"/>
+          <p:nvPr/>
+        </p:nvSpPr>
+        <p:spPr>
+          <a:xfrm>
+            <a:off x="1188720" y="530352"/>
+            <a:ext cx="9144000" cy="365760"/>
+          </a:xfrm>
+          <a:prstGeom prst="rect">
+            <a:avLst/>
+          </a:prstGeom>
+          <a:noFill/>
+        </p:spPr>
+        <p:txBody>
+          <a:bodyPr wrap="square" anchor="t" lIns="0" rIns="0" tIns="0" bIns="0">
+            <a:spAutoFit/>
+          </a:bodyPr>
+          <a:lstStyle/>
+          <a:p>
+            <a:pPr algn="l">
+              <a:lnSpc>
+                <a:spcPct val="100000"/>
+              </a:lnSpc>
+              <a:spcBef>
+                <a:spcPts val="0"/>
+              </a:spcBef>
+              <a:spcAft>
+                <a:spcPts val="500"/>
+              </a:spcAft>
+            </a:pPr>
+            <a:r>
+              <a:rPr sz="1150" b="1">
+                <a:solidFill>
+                  <a:srgbClr val="2563EB"/>
+                </a:solidFill>
+                <a:latin typeface="Segoe UI"/>
+              </a:rPr>
+              <a:t>ẢNH THẬT</a:t>
+            </a:r>
+          </a:p>
+        </p:txBody>
+      </p:sp>
+      <p:sp>
+        <p:nvSpPr>
+          <p:cNvPr id="5" name="TextBox 4"/>
+          <p:cNvSpPr txBox="1"/>
+          <p:nvPr/>
+        </p:nvSpPr>
+        <p:spPr>
+          <a:xfrm>
+            <a:off x="822960" y="841248"/>
+            <a:ext cx="10607040" cy="822960"/>
+          </a:xfrm>
+          <a:prstGeom prst="rect">
+            <a:avLst/>
+          </a:prstGeom>
+          <a:noFill/>
+        </p:spPr>
+        <p:txBody>
+          <a:bodyPr wrap="square" anchor="t" lIns="0" rIns="0" tIns="0" bIns="0">
+            <a:spAutoFit/>
+          </a:bodyPr>
+          <a:lstStyle/>
+          <a:p>
+            <a:pPr algn="l">
+              <a:lnSpc>
+                <a:spcPct val="100000"/>
+              </a:lnSpc>
+              <a:spcBef>
+                <a:spcPts val="0"/>
+              </a:spcBef>
+              <a:spcAft>
+                <a:spcPts val="500"/>
+              </a:spcAft>
+            </a:pPr>
+            <a:r>
+              <a:rPr sz="2700" b="1">
+                <a:solidFill>
+                  <a:srgbClr val="0F172A"/>
+                </a:solidFill>
+                <a:latin typeface="Segoe UI"/>
+              </a:rPr>
+              <a:t>AI &amp; Governance — cấu hình LLM</a:t>
+            </a:r>
+          </a:p>
+        </p:txBody>
+      </p:sp>
+      <p:sp>
+        <p:nvSpPr>
+          <p:cNvPr id="6" name="Rounded Rectangle 5"/>
+          <p:cNvSpPr/>
+          <p:nvPr/>
+        </p:nvSpPr>
+        <p:spPr>
+          <a:xfrm>
+            <a:off x="2835440" y="1527048"/>
+            <a:ext cx="6520815" cy="4663440"/>
+          </a:xfrm>
+          <a:prstGeom prst="roundRect">
+            <a:avLst>
+              <a:gd name="adj" fmla="val 6000"/>
+            </a:avLst>
+          </a:prstGeom>
+          <a:solidFill>
+            <a:srgbClr val="FFFFFF"/>
+          </a:solidFill>
+          <a:ln w="12700">
+            <a:solidFill>
+              <a:srgbClr val="E2E8F0"/>
+            </a:solidFill>
+          </a:ln>
+          <a:effectLst/>
+        </p:spPr>
+        <p:style>
+          <a:lnRef idx="1">
+            <a:schemeClr val="accent1"/>
+          </a:lnRef>
+          <a:fillRef idx="3">
+            <a:schemeClr val="accent1"/>
+          </a:fillRef>
+          <a:effectRef idx="2">
+            <a:schemeClr val="accent1"/>
+          </a:effectRef>
+          <a:fontRef idx="minor">
+            <a:schemeClr val="lt1"/>
+          </a:fontRef>
+        </p:style>
+        <p:txBody>
+          <a:bodyPr rtlCol="0" anchor="ctr"/>
+          <a:lstStyle/>
+          <a:p>
+            <a:pPr algn="ctr"/>
+          </a:p>
+        </p:txBody>
+      </p:sp>
+      <p:pic>
+        <p:nvPicPr>
+          <p:cNvPr id="7" name="Picture 6" descr="ai-governance.png"/>
+          <p:cNvPicPr>
+            <a:picLocks noChangeAspect="1"/>
+          </p:cNvPicPr>
+          <p:nvPr/>
+        </p:nvPicPr>
+        <p:blipFill>
+          <a:blip r:embed="rId2"/>
+          <a:stretch>
+            <a:fillRect/>
+          </a:stretch>
+        </p:blipFill>
+        <p:spPr>
+          <a:xfrm>
+            <a:off x="2881160" y="1572768"/>
+            <a:ext cx="6429375" cy="4572000"/>
+          </a:xfrm>
+          <a:prstGeom prst="rect">
+            <a:avLst/>
+          </a:prstGeom>
+        </p:spPr>
+      </p:pic>
+      <p:sp>
+        <p:nvSpPr>
+          <p:cNvPr id="8" name="TextBox 7"/>
+          <p:cNvSpPr txBox="1"/>
+          <p:nvPr/>
+        </p:nvSpPr>
+        <p:spPr>
+          <a:xfrm>
+            <a:off x="822960" y="6272783"/>
+            <a:ext cx="10607040" cy="320040"/>
+          </a:xfrm>
+          <a:prstGeom prst="rect">
+            <a:avLst/>
+          </a:prstGeom>
+          <a:noFill/>
+        </p:spPr>
+        <p:txBody>
+          <a:bodyPr wrap="square" anchor="t" lIns="0" rIns="0" tIns="0" bIns="0">
+            <a:spAutoFit/>
+          </a:bodyPr>
+          <a:lstStyle/>
+          <a:p>
+            <a:pPr algn="ctr">
+              <a:lnSpc>
+                <a:spcPct val="100000"/>
+              </a:lnSpc>
+              <a:spcBef>
+                <a:spcPts val="0"/>
+              </a:spcBef>
+              <a:spcAft>
+                <a:spcPts val="500"/>
+              </a:spcAft>
+            </a:pPr>
+            <a:r>
+              <a:rPr sz="1100" b="0">
+                <a:solidFill>
+                  <a:srgbClr val="475569"/>
+                </a:solidFill>
+                <a:latin typeface="Segoe UI"/>
+              </a:rPr>
+              <a:t>Chọn provider/model per tác vụ · bật/tắt tính năng · tham số · audit · usage.</a:t>
+            </a:r>
+          </a:p>
+        </p:txBody>
+      </p:sp>
+      <p:sp>
+        <p:nvSpPr>
+          <p:cNvPr id="9" name="TextBox 8"/>
+          <p:cNvSpPr txBox="1"/>
+          <p:nvPr/>
+        </p:nvSpPr>
+        <p:spPr>
+          <a:xfrm>
+            <a:off x="822960" y="6455664"/>
+            <a:ext cx="7315200" cy="274320"/>
+          </a:xfrm>
+          <a:prstGeom prst="rect">
+            <a:avLst/>
+          </a:prstGeom>
+          <a:noFill/>
+        </p:spPr>
+        <p:txBody>
+          <a:bodyPr wrap="square" anchor="t" lIns="0" rIns="0" tIns="0" bIns="0">
+            <a:spAutoFit/>
+          </a:bodyPr>
+          <a:lstStyle/>
+          <a:p>
+            <a:pPr algn="l">
+              <a:lnSpc>
+                <a:spcPct val="100000"/>
+              </a:lnSpc>
+              <a:spcBef>
+                <a:spcPts val="0"/>
+              </a:spcBef>
+              <a:spcAft>
+                <a:spcPts val="500"/>
+              </a:spcAft>
+            </a:pPr>
+            <a:r>
+              <a:rPr sz="900" b="0">
+                <a:solidFill>
+                  <a:srgbClr val="94A3B8"/>
+                </a:solidFill>
+                <a:latin typeface="Segoe UI"/>
+              </a:rPr>
+              <a:t>OCC-CDP · Tài liệu giới thiệu đầy đủ</a:t>
+            </a:r>
+          </a:p>
+        </p:txBody>
+      </p:sp>
+      <p:sp>
+        <p:nvSpPr>
+          <p:cNvPr id="10" name="TextBox 9"/>
+          <p:cNvSpPr txBox="1"/>
+          <p:nvPr/>
+        </p:nvSpPr>
+        <p:spPr>
+          <a:xfrm>
+            <a:off x="10515600" y="6455664"/>
+            <a:ext cx="822960" cy="274320"/>
+          </a:xfrm>
+          <a:prstGeom prst="rect">
+            <a:avLst/>
+          </a:prstGeom>
+          <a:noFill/>
+        </p:spPr>
+        <p:txBody>
+          <a:bodyPr wrap="square" anchor="t" lIns="0" rIns="0" tIns="0" bIns="0">
+            <a:spAutoFit/>
+          </a:bodyPr>
+          <a:lstStyle/>
+          <a:p>
+            <a:pPr algn="r">
+              <a:lnSpc>
+                <a:spcPct val="100000"/>
+              </a:lnSpc>
+              <a:spcBef>
+                <a:spcPts val="0"/>
+              </a:spcBef>
+              <a:spcAft>
+                <a:spcPts val="500"/>
+              </a:spcAft>
+            </a:pPr>
+            <a:r>
+              <a:rPr sz="900" b="0">
+                <a:solidFill>
+                  <a:srgbClr val="94A3B8"/>
+                </a:solidFill>
+                <a:latin typeface="Consolas"/>
+              </a:rPr>
+              <a:t>32</a:t>
+            </a:r>
+          </a:p>
+        </p:txBody>
+      </p:sp>
+    </p:spTree>
+  </p:cSld>
+  <p:clrMapOvr>
+    <a:masterClrMapping/>
+  </p:clrMapOvr>
+</p:sld>
+</file>
+
+<file path=ppt/slides/slide33.xml><?xml version="1.0" encoding="utf-8"?>
+<p:sld xmlns:a="http://schemas.openxmlformats.org/drawingml/2006/main" xmlns:p="http://schemas.openxmlformats.org/presentationml/2006/main" xmlns:r="http://schemas.openxmlformats.org/officeDocument/2006/relationships">
+  <p:cSld>
+    <p:spTree>
+      <p:nvGrpSpPr>
+        <p:cNvPr id="1" name=""/>
+        <p:cNvGrpSpPr/>
+        <p:nvPr/>
+      </p:nvGrpSpPr>
+      <p:grpSpPr/>
+      <p:sp>
+        <p:nvSpPr>
+          <p:cNvPr id="2" name="Rectangle 1"/>
+          <p:cNvSpPr/>
+          <p:nvPr/>
+        </p:nvSpPr>
+        <p:spPr>
+          <a:xfrm>
+            <a:off x="0" y="0"/>
+            <a:ext cx="12191695" cy="6858000"/>
+          </a:xfrm>
+          <a:prstGeom prst="rect">
+            <a:avLst/>
+          </a:prstGeom>
+          <a:solidFill>
+            <a:srgbClr val="F4F8FD"/>
+          </a:solidFill>
+          <a:ln>
+            <a:noFill/>
+          </a:ln>
+          <a:effectLst/>
+        </p:spPr>
+        <p:style>
+          <a:lnRef idx="1">
+            <a:schemeClr val="accent1"/>
+          </a:lnRef>
+          <a:fillRef idx="3">
+            <a:schemeClr val="accent1"/>
+          </a:fillRef>
+          <a:effectRef idx="2">
+            <a:schemeClr val="accent1"/>
+          </a:effectRef>
+          <a:fontRef idx="minor">
+            <a:schemeClr val="lt1"/>
+          </a:fontRef>
+        </p:style>
+        <p:txBody>
+          <a:bodyPr rtlCol="0" anchor="ctr"/>
+          <a:lstStyle/>
+          <a:p>
+            <a:pPr algn="ctr"/>
+          </a:p>
+        </p:txBody>
+      </p:sp>
+      <p:sp>
+        <p:nvSpPr>
+          <p:cNvPr id="3" name="Rectangle 2"/>
+          <p:cNvSpPr/>
+          <p:nvPr/>
+        </p:nvSpPr>
+        <p:spPr>
+          <a:xfrm>
+            <a:off x="822960" y="557784"/>
+            <a:ext cx="237744" cy="237744"/>
+          </a:xfrm>
+          <a:prstGeom prst="rect">
+            <a:avLst/>
+          </a:prstGeom>
+          <a:solidFill>
+            <a:srgbClr val="2563EB"/>
+          </a:solidFill>
+          <a:ln>
+            <a:noFill/>
+          </a:ln>
+          <a:effectLst/>
+        </p:spPr>
+        <p:style>
+          <a:lnRef idx="1">
+            <a:schemeClr val="accent1"/>
+          </a:lnRef>
+          <a:fillRef idx="3">
+            <a:schemeClr val="accent1"/>
+          </a:fillRef>
+          <a:effectRef idx="2">
+            <a:schemeClr val="accent1"/>
+          </a:effectRef>
+          <a:fontRef idx="minor">
+            <a:schemeClr val="lt1"/>
+          </a:fontRef>
+        </p:style>
+        <p:txBody>
+          <a:bodyPr rtlCol="0" anchor="ctr"/>
+          <a:lstStyle/>
+          <a:p>
+            <a:pPr algn="ctr"/>
+          </a:p>
+        </p:txBody>
+      </p:sp>
+      <p:sp>
+        <p:nvSpPr>
+          <p:cNvPr id="4" name="TextBox 3"/>
+          <p:cNvSpPr txBox="1"/>
+          <p:nvPr/>
+        </p:nvSpPr>
+        <p:spPr>
+          <a:xfrm>
+            <a:off x="1188720" y="530352"/>
+            <a:ext cx="9144000" cy="365760"/>
+          </a:xfrm>
+          <a:prstGeom prst="rect">
+            <a:avLst/>
+          </a:prstGeom>
+          <a:noFill/>
+        </p:spPr>
+        <p:txBody>
+          <a:bodyPr wrap="square" anchor="t" lIns="0" rIns="0" tIns="0" bIns="0">
+            <a:spAutoFit/>
+          </a:bodyPr>
+          <a:lstStyle/>
+          <a:p>
+            <a:pPr algn="l">
+              <a:lnSpc>
+                <a:spcPct val="100000"/>
+              </a:lnSpc>
+              <a:spcBef>
+                <a:spcPts val="0"/>
+              </a:spcBef>
+              <a:spcAft>
+                <a:spcPts val="500"/>
+              </a:spcAft>
+            </a:pPr>
+            <a:r>
+              <a:rPr sz="1150" b="1">
+                <a:solidFill>
+                  <a:srgbClr val="2563EB"/>
+                </a:solidFill>
+                <a:latin typeface="Segoe UI"/>
+              </a:rPr>
+              <a:t>ẢNH THẬT</a:t>
+            </a:r>
+          </a:p>
+        </p:txBody>
+      </p:sp>
+      <p:sp>
+        <p:nvSpPr>
+          <p:cNvPr id="5" name="TextBox 4"/>
+          <p:cNvSpPr txBox="1"/>
+          <p:nvPr/>
+        </p:nvSpPr>
+        <p:spPr>
+          <a:xfrm>
+            <a:off x="822960" y="841248"/>
+            <a:ext cx="10607040" cy="822960"/>
+          </a:xfrm>
+          <a:prstGeom prst="rect">
+            <a:avLst/>
+          </a:prstGeom>
+          <a:noFill/>
+        </p:spPr>
+        <p:txBody>
+          <a:bodyPr wrap="square" anchor="t" lIns="0" rIns="0" tIns="0" bIns="0">
+            <a:spAutoFit/>
+          </a:bodyPr>
+          <a:lstStyle/>
+          <a:p>
+            <a:pPr algn="l">
+              <a:lnSpc>
+                <a:spcPct val="100000"/>
+              </a:lnSpc>
+              <a:spcBef>
+                <a:spcPts val="0"/>
+              </a:spcBef>
+              <a:spcAft>
+                <a:spcPts val="500"/>
+              </a:spcAft>
+            </a:pPr>
+            <a:r>
+              <a:rPr sz="2700" b="1">
+                <a:solidFill>
+                  <a:srgbClr val="0F172A"/>
+                </a:solidFill>
+                <a:latin typeface="Segoe UI"/>
+              </a:rPr>
+              <a:t>Trợ lý AI &amp; Data Ops</a:t>
+            </a:r>
+          </a:p>
+        </p:txBody>
+      </p:sp>
+      <p:sp>
+        <p:nvSpPr>
+          <p:cNvPr id="6" name="Rounded Rectangle 5"/>
+          <p:cNvSpPr/>
+          <p:nvPr/>
+        </p:nvSpPr>
+        <p:spPr>
+          <a:xfrm>
+            <a:off x="649224" y="1655064"/>
+            <a:ext cx="5422392" cy="3877056"/>
+          </a:xfrm>
+          <a:prstGeom prst="roundRect">
+            <a:avLst>
+              <a:gd name="adj" fmla="val 6000"/>
+            </a:avLst>
+          </a:prstGeom>
+          <a:solidFill>
+            <a:srgbClr val="FFFFFF"/>
+          </a:solidFill>
+          <a:ln w="12700">
+            <a:solidFill>
+              <a:srgbClr val="E2E8F0"/>
+            </a:solidFill>
+          </a:ln>
+          <a:effectLst/>
+        </p:spPr>
+        <p:style>
+          <a:lnRef idx="1">
+            <a:schemeClr val="accent1"/>
+          </a:lnRef>
+          <a:fillRef idx="3">
+            <a:schemeClr val="accent1"/>
+          </a:fillRef>
+          <a:effectRef idx="2">
+            <a:schemeClr val="accent1"/>
+          </a:effectRef>
+          <a:fontRef idx="minor">
+            <a:schemeClr val="lt1"/>
+          </a:fontRef>
+        </p:style>
+        <p:txBody>
+          <a:bodyPr rtlCol="0" anchor="ctr"/>
+          <a:lstStyle/>
+          <a:p>
+            <a:pPr algn="ctr"/>
+          </a:p>
+        </p:txBody>
+      </p:sp>
+      <p:pic>
+        <p:nvPicPr>
+          <p:cNvPr id="7" name="Picture 6" descr="assistant.png"/>
+          <p:cNvPicPr>
+            <a:picLocks noChangeAspect="1"/>
+          </p:cNvPicPr>
+          <p:nvPr/>
+        </p:nvPicPr>
+        <p:blipFill>
+          <a:blip r:embed="rId2"/>
+          <a:stretch>
+            <a:fillRect/>
+          </a:stretch>
+        </p:blipFill>
+        <p:spPr>
+          <a:xfrm>
+            <a:off x="685800" y="1691640"/>
+            <a:ext cx="5349240" cy="3803904"/>
+          </a:xfrm>
+          <a:prstGeom prst="rect">
+            <a:avLst/>
+          </a:prstGeom>
+        </p:spPr>
+      </p:pic>
+      <p:sp>
+        <p:nvSpPr>
+          <p:cNvPr id="8" name="TextBox 7"/>
+          <p:cNvSpPr txBox="1"/>
+          <p:nvPr/>
+        </p:nvSpPr>
+        <p:spPr>
+          <a:xfrm>
+            <a:off x="685800" y="5605272"/>
+            <a:ext cx="5349240" cy="320040"/>
+          </a:xfrm>
+          <a:prstGeom prst="rect">
+            <a:avLst/>
+          </a:prstGeom>
+          <a:noFill/>
+        </p:spPr>
+        <p:txBody>
+          <a:bodyPr wrap="square" anchor="t" lIns="0" rIns="0" tIns="0" bIns="0">
+            <a:spAutoFit/>
+          </a:bodyPr>
+          <a:lstStyle/>
+          <a:p>
+            <a:pPr algn="ctr">
+              <a:lnSpc>
+                <a:spcPct val="100000"/>
+              </a:lnSpc>
+              <a:spcBef>
+                <a:spcPts val="0"/>
+              </a:spcBef>
+              <a:spcAft>
+                <a:spcPts val="500"/>
+              </a:spcAft>
+            </a:pPr>
+            <a:r>
+              <a:rPr sz="1050" b="1">
+                <a:solidFill>
+                  <a:srgbClr val="475569"/>
+                </a:solidFill>
+                <a:latin typeface="Segoe UI"/>
+              </a:rPr>
+              <a:t>Trợ lý AI (generative)</a:t>
+            </a:r>
+          </a:p>
+        </p:txBody>
+      </p:sp>
+      <p:sp>
+        <p:nvSpPr>
+          <p:cNvPr id="9" name="Rounded Rectangle 8"/>
+          <p:cNvSpPr/>
+          <p:nvPr/>
+        </p:nvSpPr>
+        <p:spPr>
+          <a:xfrm>
+            <a:off x="6181344" y="1655064"/>
+            <a:ext cx="5422392" cy="3877056"/>
+          </a:xfrm>
+          <a:prstGeom prst="roundRect">
+            <a:avLst>
+              <a:gd name="adj" fmla="val 6000"/>
+            </a:avLst>
+          </a:prstGeom>
+          <a:solidFill>
+            <a:srgbClr val="FFFFFF"/>
+          </a:solidFill>
+          <a:ln w="12700">
+            <a:solidFill>
+              <a:srgbClr val="E2E8F0"/>
+            </a:solidFill>
+          </a:ln>
+          <a:effectLst/>
+        </p:spPr>
+        <p:style>
+          <a:lnRef idx="1">
+            <a:schemeClr val="accent1"/>
+          </a:lnRef>
+          <a:fillRef idx="3">
+            <a:schemeClr val="accent1"/>
+          </a:fillRef>
+          <a:effectRef idx="2">
+            <a:schemeClr val="accent1"/>
+          </a:effectRef>
+          <a:fontRef idx="minor">
+            <a:schemeClr val="lt1"/>
+          </a:fontRef>
+        </p:style>
+        <p:txBody>
+          <a:bodyPr rtlCol="0" anchor="ctr"/>
+          <a:lstStyle/>
+          <a:p>
+            <a:pPr algn="ctr"/>
+          </a:p>
+        </p:txBody>
+      </p:sp>
+      <p:pic>
+        <p:nvPicPr>
+          <p:cNvPr id="10" name="Picture 9" descr="data-ops.png"/>
+          <p:cNvPicPr>
+            <a:picLocks noChangeAspect="1"/>
+          </p:cNvPicPr>
+          <p:nvPr/>
+        </p:nvPicPr>
+        <p:blipFill>
+          <a:blip r:embed="rId3"/>
+          <a:stretch>
+            <a:fillRect/>
+          </a:stretch>
+        </p:blipFill>
+        <p:spPr>
+          <a:xfrm>
+            <a:off x="6217920" y="1691640"/>
+            <a:ext cx="5349240" cy="3803904"/>
+          </a:xfrm>
+          <a:prstGeom prst="rect">
+            <a:avLst/>
+          </a:prstGeom>
+        </p:spPr>
+      </p:pic>
+      <p:sp>
+        <p:nvSpPr>
+          <p:cNvPr id="11" name="TextBox 10"/>
+          <p:cNvSpPr txBox="1"/>
+          <p:nvPr/>
+        </p:nvSpPr>
+        <p:spPr>
+          <a:xfrm>
+            <a:off x="6217920" y="5605272"/>
+            <a:ext cx="5349240" cy="320040"/>
+          </a:xfrm>
+          <a:prstGeom prst="rect">
+            <a:avLst/>
+          </a:prstGeom>
+          <a:noFill/>
+        </p:spPr>
+        <p:txBody>
+          <a:bodyPr wrap="square" anchor="t" lIns="0" rIns="0" tIns="0" bIns="0">
+            <a:spAutoFit/>
+          </a:bodyPr>
+          <a:lstStyle/>
+          <a:p>
+            <a:pPr algn="ctr">
+              <a:lnSpc>
+                <a:spcPct val="100000"/>
+              </a:lnSpc>
+              <a:spcBef>
+                <a:spcPts val="0"/>
+              </a:spcBef>
+              <a:spcAft>
+                <a:spcPts val="500"/>
+              </a:spcAft>
+            </a:pPr>
+            <a:r>
+              <a:rPr sz="1050" b="1">
+                <a:solidFill>
+                  <a:srgbClr val="475569"/>
+                </a:solidFill>
+                <a:latin typeface="Segoe UI"/>
+              </a:rPr>
+              <a:t>Data Ops (master data)</a:t>
+            </a:r>
+          </a:p>
+        </p:txBody>
+      </p:sp>
+      <p:sp>
+        <p:nvSpPr>
+          <p:cNvPr id="12" name="TextBox 11"/>
+          <p:cNvSpPr txBox="1"/>
+          <p:nvPr/>
+        </p:nvSpPr>
+        <p:spPr>
+          <a:xfrm>
+            <a:off x="822960" y="6455664"/>
+            <a:ext cx="7315200" cy="274320"/>
+          </a:xfrm>
+          <a:prstGeom prst="rect">
+            <a:avLst/>
+          </a:prstGeom>
+          <a:noFill/>
+        </p:spPr>
+        <p:txBody>
+          <a:bodyPr wrap="square" anchor="t" lIns="0" rIns="0" tIns="0" bIns="0">
+            <a:spAutoFit/>
+          </a:bodyPr>
+          <a:lstStyle/>
+          <a:p>
+            <a:pPr algn="l">
+              <a:lnSpc>
+                <a:spcPct val="100000"/>
+              </a:lnSpc>
+              <a:spcBef>
+                <a:spcPts val="0"/>
+              </a:spcBef>
+              <a:spcAft>
+                <a:spcPts val="500"/>
+              </a:spcAft>
+            </a:pPr>
+            <a:r>
+              <a:rPr sz="900" b="0">
+                <a:solidFill>
+                  <a:srgbClr val="94A3B8"/>
+                </a:solidFill>
+                <a:latin typeface="Segoe UI"/>
+              </a:rPr>
+              <a:t>OCC-CDP · Tài liệu giới thiệu đầy đủ</a:t>
+            </a:r>
+          </a:p>
+        </p:txBody>
+      </p:sp>
+      <p:sp>
+        <p:nvSpPr>
+          <p:cNvPr id="13" name="TextBox 12"/>
+          <p:cNvSpPr txBox="1"/>
+          <p:nvPr/>
+        </p:nvSpPr>
+        <p:spPr>
+          <a:xfrm>
+            <a:off x="10515600" y="6455664"/>
+            <a:ext cx="822960" cy="274320"/>
+          </a:xfrm>
+          <a:prstGeom prst="rect">
+            <a:avLst/>
+          </a:prstGeom>
+          <a:noFill/>
+        </p:spPr>
+        <p:txBody>
+          <a:bodyPr wrap="square" anchor="t" lIns="0" rIns="0" tIns="0" bIns="0">
+            <a:spAutoFit/>
+          </a:bodyPr>
+          <a:lstStyle/>
+          <a:p>
+            <a:pPr algn="r">
+              <a:lnSpc>
+                <a:spcPct val="100000"/>
+              </a:lnSpc>
+              <a:spcBef>
+                <a:spcPts val="0"/>
+              </a:spcBef>
+              <a:spcAft>
+                <a:spcPts val="500"/>
+              </a:spcAft>
+            </a:pPr>
+            <a:r>
+              <a:rPr sz="900" b="0">
+                <a:solidFill>
+                  <a:srgbClr val="94A3B8"/>
+                </a:solidFill>
+                <a:latin typeface="Consolas"/>
+              </a:rPr>
+              <a:t>33</a:t>
+            </a:r>
+          </a:p>
+        </p:txBody>
+      </p:sp>
+    </p:spTree>
+  </p:cSld>
+  <p:clrMapOvr>
+    <a:masterClrMapping/>
+  </p:clrMapOvr>
+</p:sld>
+</file>
+
+<file path=ppt/slides/slide34.xml><?xml version="1.0" encoding="utf-8"?>
+<p:sld xmlns:a="http://schemas.openxmlformats.org/drawingml/2006/main" xmlns:p="http://schemas.openxmlformats.org/presentationml/2006/main" xmlns:r="http://schemas.openxmlformats.org/officeDocument/2006/relationships">
+  <p:cSld>
+    <p:spTree>
+      <p:nvGrpSpPr>
+        <p:cNvPr id="1" name=""/>
+        <p:cNvGrpSpPr/>
+        <p:nvPr/>
+      </p:nvGrpSpPr>
+      <p:grpSpPr/>
+      <p:sp>
+        <p:nvSpPr>
+          <p:cNvPr id="2" name="Rectangle 1"/>
+          <p:cNvSpPr/>
+          <p:nvPr/>
+        </p:nvSpPr>
+        <p:spPr>
+          <a:xfrm>
+            <a:off x="0" y="0"/>
+            <a:ext cx="12191695" cy="6858000"/>
+          </a:xfrm>
+          <a:prstGeom prst="rect">
+            <a:avLst/>
+          </a:prstGeom>
+          <a:solidFill>
+            <a:srgbClr val="FFFFFF"/>
+          </a:solidFill>
+          <a:ln>
+            <a:noFill/>
+          </a:ln>
+          <a:effectLst/>
+        </p:spPr>
+        <p:style>
+          <a:lnRef idx="1">
+            <a:schemeClr val="accent1"/>
+          </a:lnRef>
+          <a:fillRef idx="3">
+            <a:schemeClr val="accent1"/>
+          </a:fillRef>
+          <a:effectRef idx="2">
+            <a:schemeClr val="accent1"/>
+          </a:effectRef>
+          <a:fontRef idx="minor">
+            <a:schemeClr val="lt1"/>
+          </a:fontRef>
+        </p:style>
+        <p:txBody>
+          <a:bodyPr rtlCol="0" anchor="ctr"/>
+          <a:lstStyle/>
+          <a:p>
+            <a:pPr algn="ctr"/>
+          </a:p>
+        </p:txBody>
+      </p:sp>
+      <p:pic>
+        <p:nvPicPr>
+          <p:cNvPr id="3" name="Picture 2" descr="hero.png"/>
+          <p:cNvPicPr>
+            <a:picLocks noChangeAspect="1"/>
+          </p:cNvPicPr>
+          <p:nvPr/>
+        </p:nvPicPr>
+        <p:blipFill>
+          <a:blip r:embed="rId2"/>
+          <a:stretch>
+            <a:fillRect/>
+          </a:stretch>
+        </p:blipFill>
+        <p:spPr>
+          <a:xfrm>
+            <a:off x="0" y="0"/>
+            <a:ext cx="12191695" cy="4220202"/>
+          </a:xfrm>
+          <a:prstGeom prst="rect">
+            <a:avLst/>
+          </a:prstGeom>
+        </p:spPr>
+      </p:pic>
+      <p:sp>
+        <p:nvSpPr>
+          <p:cNvPr id="4" name="Rectangle 3"/>
+          <p:cNvSpPr/>
+          <p:nvPr/>
+        </p:nvSpPr>
+        <p:spPr>
+          <a:xfrm>
+            <a:off x="0" y="4211058"/>
+            <a:ext cx="12191695" cy="2646941"/>
+          </a:xfrm>
+          <a:prstGeom prst="rect">
+            <a:avLst/>
+          </a:prstGeom>
+          <a:solidFill>
+            <a:srgbClr val="FFFFFF"/>
+          </a:solidFill>
+          <a:ln>
+            <a:noFill/>
+          </a:ln>
+          <a:effectLst/>
+        </p:spPr>
+        <p:style>
+          <a:lnRef idx="1">
+            <a:schemeClr val="accent1"/>
+          </a:lnRef>
+          <a:fillRef idx="3">
+            <a:schemeClr val="accent1"/>
+          </a:fillRef>
+          <a:effectRef idx="2">
+            <a:schemeClr val="accent1"/>
+          </a:effectRef>
+          <a:fontRef idx="minor">
+            <a:schemeClr val="lt1"/>
+          </a:fontRef>
+        </p:style>
+        <p:txBody>
+          <a:bodyPr rtlCol="0" anchor="ctr"/>
+          <a:lstStyle/>
+          <a:p>
+            <a:pPr algn="ctr"/>
+          </a:p>
+        </p:txBody>
+      </p:sp>
+      <p:sp>
+        <p:nvSpPr>
+          <p:cNvPr id="5" name="TextBox 4"/>
+          <p:cNvSpPr txBox="1"/>
+          <p:nvPr/>
+        </p:nvSpPr>
+        <p:spPr>
+          <a:xfrm>
+            <a:off x="822960" y="868680"/>
+            <a:ext cx="10058400" cy="457200"/>
+          </a:xfrm>
+          <a:prstGeom prst="rect">
+            <a:avLst/>
+          </a:prstGeom>
+          <a:noFill/>
+        </p:spPr>
+        <p:txBody>
+          <a:bodyPr wrap="square" anchor="t" lIns="0" rIns="0" tIns="0" bIns="0">
+            <a:spAutoFit/>
+          </a:bodyPr>
+          <a:lstStyle/>
+          <a:p>
+            <a:pPr algn="l">
+              <a:lnSpc>
+                <a:spcPct val="100000"/>
+              </a:lnSpc>
+              <a:spcBef>
+                <a:spcPts val="0"/>
+              </a:spcBef>
+              <a:spcAft>
+                <a:spcPts val="500"/>
+              </a:spcAft>
+            </a:pPr>
+            <a:r>
+              <a:rPr sz="1500" b="1">
+                <a:solidFill>
+                  <a:srgbClr val="FFFFFF"/>
+                </a:solidFill>
+                <a:latin typeface="Segoe UI"/>
+              </a:rPr>
+              <a:t>OCC-CDP</a:t>
+            </a:r>
+          </a:p>
+        </p:txBody>
+      </p:sp>
+      <p:sp>
+        <p:nvSpPr>
+          <p:cNvPr id="6" name="TextBox 5"/>
+          <p:cNvSpPr txBox="1"/>
+          <p:nvPr/>
+        </p:nvSpPr>
+        <p:spPr>
+          <a:xfrm>
+            <a:off x="822960" y="1554480"/>
+            <a:ext cx="10607040" cy="1463040"/>
+          </a:xfrm>
+          <a:prstGeom prst="rect">
+            <a:avLst/>
+          </a:prstGeom>
+          <a:noFill/>
+        </p:spPr>
+        <p:txBody>
+          <a:bodyPr wrap="square" anchor="t" lIns="0" rIns="0" tIns="0" bIns="0">
+            <a:spAutoFit/>
+          </a:bodyPr>
+          <a:lstStyle/>
+          <a:p>
+            <a:pPr algn="l">
+              <a:lnSpc>
+                <a:spcPct val="105000"/>
+              </a:lnSpc>
+              <a:spcBef>
+                <a:spcPts val="0"/>
+              </a:spcBef>
+              <a:spcAft>
+                <a:spcPts val="500"/>
+              </a:spcAft>
+            </a:pPr>
+            <a:r>
+              <a:rPr sz="3400" b="1">
+                <a:solidFill>
+                  <a:srgbClr val="FFFFFF"/>
+                </a:solidFill>
+                <a:latin typeface="Segoe UI"/>
+              </a:rPr>
+              <a:t>Một nền dữ liệu.</a:t>
+            </a:r>
+          </a:p>
+          <a:p>
+            <a:pPr algn="l">
+              <a:lnSpc>
+                <a:spcPct val="105000"/>
+              </a:lnSpc>
+              <a:spcBef>
+                <a:spcPts val="0"/>
+              </a:spcBef>
+              <a:spcAft>
+                <a:spcPts val="500"/>
+              </a:spcAft>
+            </a:pPr>
+            <a:r>
+              <a:rPr sz="3400" b="1">
+                <a:solidFill>
+                  <a:srgbClr val="DCEBFF"/>
+                </a:solidFill>
+                <a:latin typeface="Segoe UI"/>
+              </a:rPr>
+              <a:t>Toàn bộ giá trị khách hàng.</a:t>
+            </a:r>
+          </a:p>
+        </p:txBody>
+      </p:sp>
+      <p:sp>
+        <p:nvSpPr>
+          <p:cNvPr id="7" name="Rectangle 6"/>
+          <p:cNvSpPr/>
+          <p:nvPr/>
+        </p:nvSpPr>
+        <p:spPr>
+          <a:xfrm>
+            <a:off x="822960" y="4549386"/>
+            <a:ext cx="137160" cy="137160"/>
+          </a:xfrm>
+          <a:prstGeom prst="rect">
+            <a:avLst/>
+          </a:prstGeom>
+          <a:solidFill>
+            <a:srgbClr val="2563EB"/>
+          </a:solidFill>
+          <a:ln>
+            <a:noFill/>
+          </a:ln>
+          <a:effectLst/>
+        </p:spPr>
+        <p:style>
+          <a:lnRef idx="1">
+            <a:schemeClr val="accent1"/>
+          </a:lnRef>
+          <a:fillRef idx="3">
+            <a:schemeClr val="accent1"/>
+          </a:fillRef>
+          <a:effectRef idx="2">
+            <a:schemeClr val="accent1"/>
+          </a:effectRef>
+          <a:fontRef idx="minor">
+            <a:schemeClr val="lt1"/>
+          </a:fontRef>
+        </p:style>
+        <p:txBody>
+          <a:bodyPr rtlCol="0" anchor="ctr"/>
+          <a:lstStyle/>
+          <a:p>
+            <a:pPr algn="ctr"/>
+          </a:p>
+        </p:txBody>
+      </p:sp>
+      <p:sp>
+        <p:nvSpPr>
+          <p:cNvPr id="8" name="TextBox 7"/>
+          <p:cNvSpPr txBox="1"/>
+          <p:nvPr/>
+        </p:nvSpPr>
+        <p:spPr>
+          <a:xfrm>
+            <a:off x="1097280" y="4494522"/>
+            <a:ext cx="10332720" cy="457200"/>
+          </a:xfrm>
+          <a:prstGeom prst="rect">
+            <a:avLst/>
+          </a:prstGeom>
+          <a:noFill/>
+        </p:spPr>
+        <p:txBody>
+          <a:bodyPr wrap="square" anchor="t" lIns="0" rIns="0" tIns="0" bIns="0">
+            <a:spAutoFit/>
+          </a:bodyPr>
+          <a:lstStyle/>
+          <a:p>
+            <a:pPr algn="l">
+              <a:lnSpc>
+                <a:spcPct val="100000"/>
+              </a:lnSpc>
+              <a:spcBef>
+                <a:spcPts val="0"/>
+              </a:spcBef>
+              <a:spcAft>
+                <a:spcPts val="500"/>
+              </a:spcAft>
+            </a:pPr>
+            <a:r>
+              <a:rPr sz="1400" b="1">
+                <a:solidFill>
+                  <a:srgbClr val="0F172A"/>
+                </a:solidFill>
+                <a:latin typeface="Segoe UI"/>
+              </a:rPr>
+              <a:t>Nền tảng self-host, audit-grade  </a:t>
+            </a:r>
+            <a:r>
+              <a:rPr sz="1250" b="0">
+                <a:solidFill>
+                  <a:srgbClr val="475569"/>
+                </a:solidFill>
+                <a:latin typeface="Segoe UI"/>
+              </a:rPr>
+              <a:t>hợp nhất danh tính · loyalty · consent trong 1 transaction ACID.</a:t>
+            </a:r>
+          </a:p>
+        </p:txBody>
+      </p:sp>
+      <p:sp>
+        <p:nvSpPr>
+          <p:cNvPr id="9" name="Rectangle 8"/>
+          <p:cNvSpPr/>
+          <p:nvPr/>
+        </p:nvSpPr>
+        <p:spPr>
+          <a:xfrm>
+            <a:off x="822960" y="5116314"/>
+            <a:ext cx="137160" cy="137160"/>
+          </a:xfrm>
+          <a:prstGeom prst="rect">
+            <a:avLst/>
+          </a:prstGeom>
+          <a:solidFill>
+            <a:srgbClr val="2563EB"/>
+          </a:solidFill>
+          <a:ln>
+            <a:noFill/>
+          </a:ln>
+          <a:effectLst/>
+        </p:spPr>
+        <p:style>
+          <a:lnRef idx="1">
+            <a:schemeClr val="accent1"/>
+          </a:lnRef>
+          <a:fillRef idx="3">
+            <a:schemeClr val="accent1"/>
+          </a:fillRef>
+          <a:effectRef idx="2">
+            <a:schemeClr val="accent1"/>
+          </a:effectRef>
+          <a:fontRef idx="minor">
+            <a:schemeClr val="lt1"/>
+          </a:fontRef>
+        </p:style>
+        <p:txBody>
+          <a:bodyPr rtlCol="0" anchor="ctr"/>
+          <a:lstStyle/>
+          <a:p>
+            <a:pPr algn="ctr"/>
+          </a:p>
+        </p:txBody>
+      </p:sp>
+      <p:sp>
+        <p:nvSpPr>
+          <p:cNvPr id="10" name="TextBox 9"/>
+          <p:cNvSpPr txBox="1"/>
+          <p:nvPr/>
+        </p:nvSpPr>
+        <p:spPr>
+          <a:xfrm>
+            <a:off x="1097280" y="5061450"/>
+            <a:ext cx="10332720" cy="457200"/>
+          </a:xfrm>
+          <a:prstGeom prst="rect">
+            <a:avLst/>
+          </a:prstGeom>
+          <a:noFill/>
+        </p:spPr>
+        <p:txBody>
+          <a:bodyPr wrap="square" anchor="t" lIns="0" rIns="0" tIns="0" bIns="0">
+            <a:spAutoFit/>
+          </a:bodyPr>
+          <a:lstStyle/>
+          <a:p>
+            <a:pPr algn="l">
+              <a:lnSpc>
+                <a:spcPct val="100000"/>
+              </a:lnSpc>
+              <a:spcBef>
+                <a:spcPts val="0"/>
+              </a:spcBef>
+              <a:spcAft>
+                <a:spcPts val="500"/>
+              </a:spcAft>
+            </a:pPr>
+            <a:r>
+              <a:rPr sz="1400" b="1">
+                <a:solidFill>
+                  <a:srgbClr val="0F172A"/>
+                </a:solidFill>
+                <a:latin typeface="Segoe UI"/>
+              </a:rPr>
+              <a:t>AI biến dữ liệu thành quyết định  </a:t>
+            </a:r>
+            <a:r>
+              <a:rPr sz="1250" b="0">
+                <a:solidFill>
+                  <a:srgbClr val="475569"/>
+                </a:solidFill>
+                <a:latin typeface="Segoe UI"/>
+              </a:rPr>
+              <a:t>phân tích hành vi, dự đoán sản phẩm, forecast, decisioning, copilot.</a:t>
+            </a:r>
+          </a:p>
+        </p:txBody>
+      </p:sp>
+      <p:sp>
+        <p:nvSpPr>
+          <p:cNvPr id="11" name="Rectangle 10"/>
+          <p:cNvSpPr/>
+          <p:nvPr/>
+        </p:nvSpPr>
+        <p:spPr>
+          <a:xfrm>
+            <a:off x="822960" y="5683242"/>
+            <a:ext cx="137160" cy="137160"/>
+          </a:xfrm>
+          <a:prstGeom prst="rect">
+            <a:avLst/>
+          </a:prstGeom>
+          <a:solidFill>
+            <a:srgbClr val="2563EB"/>
+          </a:solidFill>
+          <a:ln>
+            <a:noFill/>
+          </a:ln>
+          <a:effectLst/>
+        </p:spPr>
+        <p:style>
+          <a:lnRef idx="1">
+            <a:schemeClr val="accent1"/>
+          </a:lnRef>
+          <a:fillRef idx="3">
+            <a:schemeClr val="accent1"/>
+          </a:fillRef>
+          <a:effectRef idx="2">
+            <a:schemeClr val="accent1"/>
+          </a:effectRef>
+          <a:fontRef idx="minor">
+            <a:schemeClr val="lt1"/>
+          </a:fontRef>
+        </p:style>
+        <p:txBody>
+          <a:bodyPr rtlCol="0" anchor="ctr"/>
+          <a:lstStyle/>
+          <a:p>
+            <a:pPr algn="ctr"/>
+          </a:p>
+        </p:txBody>
+      </p:sp>
+      <p:sp>
+        <p:nvSpPr>
+          <p:cNvPr id="12" name="TextBox 11"/>
+          <p:cNvSpPr txBox="1"/>
+          <p:nvPr/>
+        </p:nvSpPr>
+        <p:spPr>
+          <a:xfrm>
+            <a:off x="1097280" y="5628378"/>
+            <a:ext cx="10332720" cy="457200"/>
+          </a:xfrm>
+          <a:prstGeom prst="rect">
+            <a:avLst/>
+          </a:prstGeom>
+          <a:noFill/>
+        </p:spPr>
+        <p:txBody>
+          <a:bodyPr wrap="square" anchor="t" lIns="0" rIns="0" tIns="0" bIns="0">
+            <a:spAutoFit/>
+          </a:bodyPr>
+          <a:lstStyle/>
+          <a:p>
+            <a:pPr algn="l">
+              <a:lnSpc>
+                <a:spcPct val="100000"/>
+              </a:lnSpc>
+              <a:spcBef>
+                <a:spcPts val="0"/>
+              </a:spcBef>
+              <a:spcAft>
+                <a:spcPts val="500"/>
+              </a:spcAft>
+            </a:pPr>
+            <a:r>
+              <a:rPr sz="1400" b="1">
+                <a:solidFill>
+                  <a:srgbClr val="0F172A"/>
+                </a:solidFill>
+                <a:latin typeface="Segoe UI"/>
+              </a:rPr>
+              <a:t>Chất lượng chứng minh được  </a:t>
+            </a:r>
+            <a:r>
+              <a:rPr sz="1250" b="0">
+                <a:solidFill>
+                  <a:srgbClr val="475569"/>
+                </a:solidFill>
+                <a:latin typeface="Segoe UI"/>
+              </a:rPr>
+              <a:t>UAT 78/78, expert 33/33, mutation 5/5, TDD toàn diện.</a:t>
+            </a:r>
+          </a:p>
+        </p:txBody>
+      </p:sp>
+      <p:sp>
+        <p:nvSpPr>
+          <p:cNvPr id="13" name="TextBox 12"/>
+          <p:cNvSpPr txBox="1"/>
+          <p:nvPr/>
+        </p:nvSpPr>
+        <p:spPr>
+          <a:xfrm>
+            <a:off x="822960" y="6419088"/>
+            <a:ext cx="10515600" cy="365760"/>
+          </a:xfrm>
+          <a:prstGeom prst="rect">
+            <a:avLst/>
+          </a:prstGeom>
+          <a:noFill/>
+        </p:spPr>
+        <p:txBody>
+          <a:bodyPr wrap="square" anchor="t" lIns="0" rIns="0" tIns="0" bIns="0">
+            <a:spAutoFit/>
+          </a:bodyPr>
+          <a:lstStyle/>
+          <a:p>
+            <a:pPr algn="l">
+              <a:lnSpc>
+                <a:spcPct val="100000"/>
+              </a:lnSpc>
+              <a:spcBef>
+                <a:spcPts val="0"/>
+              </a:spcBef>
+              <a:spcAft>
+                <a:spcPts val="500"/>
+              </a:spcAft>
+            </a:pPr>
+            <a:r>
+              <a:rPr sz="1050" b="0">
+                <a:solidFill>
+                  <a:srgbClr val="94A3B8"/>
+                </a:solidFill>
+                <a:latin typeface="Segoe UI"/>
+              </a:rPr>
+              <a:t>Tài liệu chi tiết (markdown): C:\AICDP\docs   ·   github.com/trungtm78/AICDP</a:t>
             </a:r>
           </a:p>
         </p:txBody>

</xml_diff>